<commit_message>
feat(v5): complete post-audit hardening, ground SKU observation, align notes & scope, and regenerate deliverables
</commit_message>
<xml_diff>
--- a/ReturnLens_v5.pptx
+++ b/ReturnLens_v5.pptx
@@ -722,12 +722,12 @@
           </a:p>
           <a:p>
             <a:r>
-              <a:t>- Core Benchmark Scenario (Case B): Buyer ordered White Headphones (HEAD-WHT-02, ₹1,499), but unboxing frame 00:07 shows black headphones.</a:t>
-            </a:r>
-          </a:p>
-          <a:p>
-            <a:r>
-              <a:t>- Visual Grounding Honesty: The agent does NOT claim to read an unreadable SKU barcode from frame 00:07. It factually observes: 'Observed Color: Midnight Black · Exact SKU: Not verified · Tag: Not visible in cited frame'. Frame citations provide a traceable reference, not proof of footage authenticity.</a:t>
+              <a:t>- Core Benchmark Scenario (Case B): Buyer ordered White Headphones (HEAD-WHT-02, ₹1,499), but unboxing frame 00:07 shows black casing.</a:t>
+            </a:r>
+          </a:p>
+          <a:p>
+            <a:r>
+              <a:t>- Visual Grounding Honesty: The agent does NOT claim to verify the exact SKU barcode from frame 00:07. It factually observes: 'Black casing (color-consistent with HEAD-BLK-09) · Barcode unverified · SKU not verified'. Frame citations provide a traceable reference, not proof of footage authenticity.</a:t>
             </a:r>
           </a:p>
           <a:p>
@@ -737,22 +737,22 @@
           </a:p>
           <a:p>
             <a:r>
-              <a:t>- Three Clear Merchant Options:</a:t>
-            </a:r>
-          </a:p>
-          <a:p>
-            <a:r>
-              <a:t>  1. Request unboxing video with packaging label / serial number visible.</a:t>
-            </a:r>
-          </a:p>
-          <a:p>
-            <a:r>
-              <a:t>  2. Reject return under policy (item does not match order record).</a:t>
-            </a:r>
-          </a:p>
-          <a:p>
-            <a:r>
-              <a:t>  3. Override &amp; approve if seller acknowledges known warehouse fulfillment error.</a:t>
+              <a:t>- Three Preserved Seller Options (matching slide face):</a:t>
+            </a:r>
+          </a:p>
+          <a:p>
+            <a:r>
+              <a:t>  1. Accept as warehouse mis-shipment.</a:t>
+            </a:r>
+          </a:p>
+          <a:p>
+            <a:r>
+              <a:t>  2. Request photo of outside-box shipping label.</a:t>
+            </a:r>
+          </a:p>
+          <a:p>
+            <a:r>
+              <a:t>  3. Hold return for physical parcel inspection.</a:t>
             </a:r>
           </a:p>
           <a:p>
@@ -878,6 +878,11 @@
           <a:p>
             <a:r>
               <a:t>  3. Sequence: Refund proposal -&gt; Code validation -&gt; Seller approval -&gt; Revalidation -&gt; Draft creation -&gt; Receipt -&gt; Release. LLMs possess zero capability to call payment gateways directly.</a:t>
+            </a:r>
+          </a:p>
+          <a:p>
+            <a:r>
+              <a:t>- Security Hardening: Authorization signature binds case ID, SHA256 evidence hash, and policy version. State is revalidated before any draft release.</a:t>
             </a:r>
           </a:p>
         </p:txBody>
@@ -4483,8 +4488,8 @@
         </p:nvSpPr>
         <p:spPr>
           <a:xfrm>
-            <a:off x="4937760" y="1828800"/>
-            <a:ext cx="3246120" cy="2011680"/>
+            <a:off x="4937760" y="1783080"/>
+            <a:ext cx="3246120" cy="2194560"/>
           </a:xfrm>
           <a:prstGeom prst="roundRect">
             <a:avLst/>
@@ -4528,8 +4533,8 @@
         </p:nvSpPr>
         <p:spPr>
           <a:xfrm>
-            <a:off x="5074920" y="2011680"/>
-            <a:ext cx="2971800" cy="1737360"/>
+            <a:off x="5074920" y="1965960"/>
+            <a:ext cx="2971800" cy="1920240"/>
           </a:xfrm>
           <a:prstGeom prst="rect">
             <a:avLst/>
@@ -4598,8 +4603,8 @@
         </p:nvSpPr>
         <p:spPr>
           <a:xfrm>
-            <a:off x="8339328" y="1828800"/>
-            <a:ext cx="3246120" cy="2011680"/>
+            <a:off x="8339328" y="1783080"/>
+            <a:ext cx="3246120" cy="2194560"/>
           </a:xfrm>
           <a:prstGeom prst="roundRect">
             <a:avLst/>
@@ -4643,8 +4648,8 @@
         </p:nvSpPr>
         <p:spPr>
           <a:xfrm>
-            <a:off x="8476488" y="2011680"/>
-            <a:ext cx="2971800" cy="1737360"/>
+            <a:off x="8476488" y="1965960"/>
+            <a:ext cx="2971800" cy="1920240"/>
           </a:xfrm>
           <a:prstGeom prst="rect">
             <a:avLst/>
@@ -4671,7 +4676,7 @@
           </a:p>
           <a:p>
             <a:pPr>
-              <a:defRPr sz="1600" b="1">
+              <a:defRPr sz="1500" b="1">
                 <a:solidFill>
                   <a:srgbClr val="962D22"/>
                 </a:solidFill>
@@ -4679,7 +4684,7 @@
               </a:defRPr>
             </a:pPr>
             <a:r>
-              <a:t>HEAD-BLK-09 (Midnight Black)</a:t>
+              <a:t>Black Casing (HEAD-BLK-09 Color)</a:t>
             </a:r>
           </a:p>
           <a:p>
@@ -4692,11 +4697,11 @@
               </a:defRPr>
             </a:pPr>
             <a:r>
-              <a:t>Observed: Black casing</a:t>
+              <a:t>Color-consistent with HEAD-BLK-09</a:t>
             </a:r>
             <a:br/>
             <a:r>
-              <a:t>Exact Barcode: Unverified in frame</a:t>
+              <a:t>Barcode: Unverified (SKU not verified)</a:t>
             </a:r>
             <a:br/>
             <a:r>
@@ -4713,8 +4718,8 @@
         </p:nvSpPr>
         <p:spPr>
           <a:xfrm>
-            <a:off x="4937760" y="4023360"/>
-            <a:ext cx="6647688" cy="658368"/>
+            <a:off x="4937760" y="4160520"/>
+            <a:ext cx="6647688" cy="685800"/>
           </a:xfrm>
           <a:prstGeom prst="roundRect">
             <a:avLst/>
@@ -4758,8 +4763,8 @@
         </p:nvSpPr>
         <p:spPr>
           <a:xfrm>
-            <a:off x="5074920" y="4133088"/>
-            <a:ext cx="6373368" cy="438912"/>
+            <a:off x="5074920" y="4270248"/>
+            <a:ext cx="6373368" cy="457200"/>
           </a:xfrm>
           <a:prstGeom prst="rect">
             <a:avLst/>
@@ -4794,8 +4799,8 @@
         </p:nvSpPr>
         <p:spPr>
           <a:xfrm>
-            <a:off x="4937760" y="4846320"/>
-            <a:ext cx="4114800" cy="365760"/>
+            <a:off x="4937760" y="5001768"/>
+            <a:ext cx="2926080" cy="365760"/>
           </a:xfrm>
           <a:prstGeom prst="rect">
             <a:avLst/>
@@ -4809,7 +4814,7 @@
           <a:lstStyle/>
           <a:p>
             <a:pPr>
-              <a:defRPr sz="1050" b="1">
+              <a:defRPr sz="1000" b="1">
                 <a:solidFill>
                   <a:srgbClr val="92400E"/>
                 </a:solidFill>
@@ -4817,7 +4822,7 @@
               </a:defRPr>
             </a:pPr>
             <a:r>
-              <a:t>● SELLER AUTHORIZATION REQUIRED (FAIL-CLOSED)</a:t>
+              <a:t>● SELLER GATE (FAIL-CLOSED)</a:t>
             </a:r>
           </a:p>
         </p:txBody>
@@ -4830,16 +4835,20 @@
         </p:nvSpPr>
         <p:spPr>
           <a:xfrm>
-            <a:off x="9235440" y="4800600"/>
-            <a:ext cx="2331720" cy="438912"/>
+            <a:off x="7909560" y="4956048"/>
+            <a:ext cx="1691640" cy="411480"/>
           </a:xfrm>
           <a:prstGeom prst="roundRect">
             <a:avLst/>
           </a:prstGeom>
           <a:solidFill>
-            <a:srgbClr val="006B54"/>
+            <a:srgbClr val="F2EFEB"/>
           </a:solidFill>
-          <a:ln/>
+          <a:ln w="12700">
+            <a:solidFill>
+              <a:srgbClr val="CDC5B8"/>
+            </a:solidFill>
+          </a:ln>
         </p:spPr>
         <p:style>
           <a:lnRef idx="1">
@@ -4860,35 +4869,35 @@
           <a:lstStyle/>
           <a:p>
             <a:pPr algn="ctr">
-              <a:defRPr sz="1100" b="1">
-                <a:solidFill>
-                  <a:srgbClr val="FFFFFF"/>
+              <a:defRPr sz="1000" b="1">
+                <a:solidFill>
+                  <a:srgbClr val="14241E"/>
                 </a:solidFill>
                 <a:latin typeface="Inter"/>
               </a:defRPr>
             </a:pPr>
             <a:r>
-              <a:t>Review Evidence &amp; Authorize</a:t>
-            </a:r>
-          </a:p>
-        </p:txBody>
-      </p:sp>
-      <p:sp>
-        <p:nvSpPr>
-          <p:cNvPr id="18" name="Rectangle 17"/>
+              <a:t>Request Box Label</a:t>
+            </a:r>
+          </a:p>
+        </p:txBody>
+      </p:sp>
+      <p:sp>
+        <p:nvSpPr>
+          <p:cNvPr id="18" name="Rounded Rectangle 17"/>
           <p:cNvSpPr/>
           <p:nvPr/>
         </p:nvSpPr>
         <p:spPr>
           <a:xfrm>
-            <a:off x="420624" y="6400800"/>
-            <a:ext cx="11347704" cy="13716"/>
-          </a:xfrm>
-          <a:prstGeom prst="rect">
+            <a:off x="9692640" y="4956048"/>
+            <a:ext cx="1874519" cy="411480"/>
+          </a:xfrm>
+          <a:prstGeom prst="roundRect">
             <a:avLst/>
           </a:prstGeom>
           <a:solidFill>
-            <a:srgbClr val="E3DDD4"/>
+            <a:srgbClr val="006B54"/>
           </a:solidFill>
           <a:ln/>
         </p:spPr>
@@ -4910,13 +4919,64 @@
           <a:bodyPr rtlCol="0" anchor="ctr"/>
           <a:lstStyle/>
           <a:p>
+            <a:pPr algn="ctr">
+              <a:defRPr sz="1050" b="1">
+                <a:solidFill>
+                  <a:srgbClr val="FFFFFF"/>
+                </a:solidFill>
+                <a:latin typeface="Inter"/>
+              </a:defRPr>
+            </a:pPr>
+            <a:r>
+              <a:t>Review &amp; Authorize</a:t>
+            </a:r>
+          </a:p>
+        </p:txBody>
+      </p:sp>
+      <p:sp>
+        <p:nvSpPr>
+          <p:cNvPr id="19" name="Rectangle 18"/>
+          <p:cNvSpPr/>
+          <p:nvPr/>
+        </p:nvSpPr>
+        <p:spPr>
+          <a:xfrm>
+            <a:off x="420624" y="6400800"/>
+            <a:ext cx="11347704" cy="13716"/>
+          </a:xfrm>
+          <a:prstGeom prst="rect">
+            <a:avLst/>
+          </a:prstGeom>
+          <a:solidFill>
+            <a:srgbClr val="E3DDD4"/>
+          </a:solidFill>
+          <a:ln/>
+        </p:spPr>
+        <p:style>
+          <a:lnRef idx="1">
+            <a:schemeClr val="accent1"/>
+          </a:lnRef>
+          <a:fillRef idx="3">
+            <a:schemeClr val="accent1"/>
+          </a:fillRef>
+          <a:effectRef idx="2">
+            <a:schemeClr val="accent1"/>
+          </a:effectRef>
+          <a:fontRef idx="minor">
+            <a:schemeClr val="lt1"/>
+          </a:fontRef>
+        </p:style>
+        <p:txBody>
+          <a:bodyPr rtlCol="0" anchor="ctr"/>
+          <a:lstStyle/>
+          <a:p>
             <a:pPr algn="ctr"/>
           </a:p>
         </p:txBody>
       </p:sp>
       <p:sp>
         <p:nvSpPr>
-          <p:cNvPr id="19" name="TextBox 18"/>
+          <p:cNvPr id="20" name="TextBox 19"/>
           <p:cNvSpPr txBox="1"/>
           <p:nvPr/>
         </p:nvSpPr>
@@ -4952,7 +5012,7 @@
       </p:sp>
       <p:sp>
         <p:nvSpPr>
-          <p:cNvPr id="20" name="TextBox 19"/>
+          <p:cNvPr id="21" name="TextBox 20"/>
           <p:cNvSpPr txBox="1"/>
           <p:nvPr/>
         </p:nvSpPr>
@@ -6567,7 +6627,7 @@
             </a:r>
             <a:br/>
             <a:r>
-              <a:t>[ MIDNIGHT BLACK CASING DETECTED ]</a:t>
+              <a:t>[ BLACK CASING DETECTED ]</a:t>
             </a:r>
             <a:br/>
             <a:r>
@@ -6607,11 +6667,11 @@
               </a:defRPr>
             </a:pPr>
             <a:r>
-              <a:t>Observed: HEAD-BLK-09 (Midnight Black)</a:t>
+              <a:t>Observed: Black Casing (Color-consistent with HEAD-BLK-09)</a:t>
             </a:r>
             <a:br/>
             <a:r>
-              <a:t>Exact Barcode: Unverified · P-03 Color Match: FAIL</a:t>
+              <a:t>Exact SKU: Not verified (Barcode unverified) · P-03 FAIL</a:t>
             </a:r>
           </a:p>
         </p:txBody>
@@ -6625,7 +6685,7 @@
         <p:spPr>
           <a:xfrm>
             <a:off x="420624" y="5330952"/>
-            <a:ext cx="11347704" cy="914400"/>
+            <a:ext cx="11347704" cy="932688"/>
           </a:xfrm>
           <a:prstGeom prst="roundRect">
             <a:avLst/>
@@ -6670,7 +6730,7 @@
         <p:spPr>
           <a:xfrm>
             <a:off x="594360" y="5422392"/>
-            <a:ext cx="10972800" cy="731520"/>
+            <a:ext cx="10972800" cy="749808"/>
           </a:xfrm>
           <a:prstGeom prst="rect">
             <a:avLst/>
@@ -6684,7 +6744,7 @@
           <a:lstStyle/>
           <a:p>
             <a:pPr>
-              <a:defRPr sz="1200" b="1">
+              <a:defRPr sz="1250" b="1">
                 <a:solidFill>
                   <a:srgbClr val="962D22"/>
                 </a:solidFill>
@@ -6697,7 +6757,7 @@
           </a:p>
           <a:p>
             <a:pPr>
-              <a:defRPr sz="1100">
+              <a:defRPr sz="1150">
                 <a:solidFill>
                   <a:srgbClr val="243830"/>
                 </a:solidFill>
@@ -7681,7 +7741,7 @@
         <p:spPr>
           <a:xfrm>
             <a:off x="420624" y="5330952"/>
-            <a:ext cx="11347704" cy="685800"/>
+            <a:ext cx="11347704" cy="713232"/>
           </a:xfrm>
           <a:prstGeom prst="roundRect">
             <a:avLst/>
@@ -7725,8 +7785,8 @@
         </p:nvSpPr>
         <p:spPr>
           <a:xfrm>
-            <a:off x="594360" y="5440680"/>
-            <a:ext cx="10972800" cy="457200"/>
+            <a:off x="594360" y="5422392"/>
+            <a:ext cx="10972800" cy="530352"/>
           </a:xfrm>
           <a:prstGeom prst="rect">
             <a:avLst/>
@@ -7740,19 +7800,28 @@
           <a:lstStyle/>
           <a:p>
             <a:pPr>
+              <a:defRPr sz="1050" b="1">
+                <a:solidFill>
+                  <a:srgbClr val="FFD485"/>
+                </a:solidFill>
+                <a:latin typeface="IBM Plex Mono"/>
+              </a:defRPr>
+            </a:pPr>
+            <a:r>
+              <a:t>FAIL-CLOSED FINANCIAL GATE: requires_seller_approval: true · Approval binds case + evidence hash + policy version.</a:t>
+            </a:r>
+          </a:p>
+          <a:p>
+            <a:pPr>
               <a:defRPr sz="1050">
                 <a:solidFill>
-                  <a:srgbClr val="FFD485"/>
+                  <a:srgbClr val="8EABA0"/>
                 </a:solidFill>
                 <a:latin typeface="IBM Plex Mono"/>
               </a:defRPr>
             </a:pPr>
             <a:r>
-              <a:t>FAIL-CLOSED FINANCIAL GATE: requires_seller_approval: true enforced at schema layer.</a:t>
-            </a:r>
-            <a:br/>
-            <a:r>
-              <a:t>Server Cap: 0 &lt; amount &lt;= min(₹4,999, remaining_refundable, order_paid)</a:t>
+              <a:t>Server Cap: 0 &lt; amount &lt;= min(₹4,999, remaining_refundable, order_paid) · Revalidation check before draft release.</a:t>
             </a:r>
           </a:p>
         </p:txBody>
@@ -8013,7 +8082,7 @@
               </a:defRPr>
             </a:pPr>
             <a:r>
-              <a:t>Every case produces an auditable mock evidence pack. Zero hallucinated policy approvals.</a:t>
+              <a:t>Every case produces an auditable mock evidence pack. No automatic policy approvals.</a:t>
             </a:r>
           </a:p>
         </p:txBody>
@@ -8100,7 +8169,7 @@
           <a:p>
             <a:pPr>
               <a:spcAft>
-                <a:spcPts val="1200"/>
+                <a:spcPts val="1000"/>
               </a:spcAft>
               <a:defRPr sz="2000" b="1">
                 <a:solidFill>
@@ -8116,9 +8185,9 @@
           <a:p>
             <a:pPr>
               <a:spcAft>
-                <a:spcPts val="1600"/>
+                <a:spcPts val="1400"/>
               </a:spcAft>
-              <a:defRPr sz="1100">
+              <a:defRPr sz="1050">
                 <a:solidFill>
                   <a:srgbClr val="962D22"/>
                 </a:solidFill>
@@ -8130,10 +8199,18 @@
             </a:r>
             <a:br/>
             <a:r>
-              <a:t>Observed Frame 00:07: HEAD-BLK-09 (Midnight Black)</a:t>
+              <a:t>Observed Frame 00:07: Black casing</a:t>
             </a:r>
             <a:br/>
             <a:r>
+              <a:t>Color Match: Consistent with HEAD-BLK-09</a:t>
+            </a:r>
+            <a:br/>
+            <a:r>
+              <a:t>Barcode: Unverified (SKU not verified)</a:t>
+            </a:r>
+            <a:br/>
+            <a:r>
               <a:t>Policy Evaluation: P-03 Color Match: FAIL</a:t>
             </a:r>
             <a:br/>
@@ -8143,7 +8220,7 @@
           </a:p>
           <a:p>
             <a:pPr>
-              <a:defRPr sz="1200">
+              <a:defRPr sz="1150">
                 <a:solidFill>
                   <a:srgbClr val="243830"/>
                 </a:solidFill>
@@ -8377,7 +8454,7 @@
               </a:defRPr>
             </a:pPr>
             <a:r>
-              <a:t>Outcome: Agent issues re-film checklist · Case stays in WAITING_FOR_EVIDENCE · Resumes on upload (1 retry limit).</a:t>
+              <a:t>Outcome: Agent issues re-film checklist · State saved to WAITING_FOR_EVIDENCE · Resumes on upload (after 1 retry, escalates with both attempts logged; never auto-denies).</a:t>
             </a:r>
           </a:p>
         </p:txBody>
@@ -8937,7 +9014,7 @@
               </a:defRPr>
             </a:pPr>
             <a:r>
-              <a:t>Case C pause/resume state loop · 4 demo cases (A–D) · Critic review</a:t>
+              <a:t>Case C pause/resume loop · 3 core cases (A–C) + Case D sequence test · Critic review</a:t>
             </a:r>
           </a:p>
         </p:txBody>
@@ -9316,7 +9393,7 @@
               </a:defRPr>
             </a:pPr>
             <a:r>
-              <a:t>Test fixtures for Cases A–D, Case C stateful pause/resume lifecycle, fail-closed human gate testing, benchmark runner, video capture.</a:t>
+              <a:t>Test fixtures for Cases A–D, Case C pause/resume lifecycle, fail-closed human gate testing, benchmark runner, video capture.</a:t>
             </a:r>
           </a:p>
         </p:txBody>
@@ -9329,8 +9406,8 @@
         </p:nvSpPr>
         <p:spPr>
           <a:xfrm>
-            <a:off x="420624" y="5120640"/>
-            <a:ext cx="11347704" cy="1051560"/>
+            <a:off x="420624" y="5074920"/>
+            <a:ext cx="11347704" cy="1143000"/>
           </a:xfrm>
           <a:prstGeom prst="roundRect">
             <a:avLst/>
@@ -9370,8 +9447,8 @@
         </p:nvSpPr>
         <p:spPr>
           <a:xfrm>
-            <a:off x="594360" y="5257800"/>
-            <a:ext cx="4114800" cy="777240"/>
+            <a:off x="594360" y="5184648"/>
+            <a:ext cx="4114800" cy="914400"/>
           </a:xfrm>
           <a:prstGeom prst="rect">
             <a:avLst/>
@@ -9385,7 +9462,7 @@
           <a:lstStyle/>
           <a:p>
             <a:pPr>
-              <a:defRPr sz="1000" b="1">
+              <a:defRPr sz="1050" b="1">
                 <a:solidFill>
                   <a:srgbClr val="FFD485"/>
                 </a:solidFill>
@@ -9398,7 +9475,7 @@
           </a:p>
           <a:p>
             <a:pPr>
-              <a:defRPr sz="1050">
+              <a:defRPr sz="1100">
                 <a:solidFill>
                   <a:srgbClr val="DFEAE5"/>
                 </a:solidFill>
@@ -9406,7 +9483,7 @@
               </a:defRPr>
             </a:pPr>
             <a:r>
-              <a:t>Mock APIs · Policy engine · Case B mismatch · Case C re-film · Seller gate · Tiny order route</a:t>
+              <a:t>Mock APIs · Policy engine · Cases A–C + Case D test · Approval binding · Seller gate · Tiny order route</a:t>
             </a:r>
           </a:p>
         </p:txBody>
@@ -9419,8 +9496,8 @@
         </p:nvSpPr>
         <p:spPr>
           <a:xfrm>
-            <a:off x="4937760" y="5257800"/>
-            <a:ext cx="3840480" cy="777240"/>
+            <a:off x="4937760" y="5184648"/>
+            <a:ext cx="3840480" cy="914400"/>
           </a:xfrm>
           <a:prstGeom prst="rect">
             <a:avLst/>
@@ -9434,7 +9511,7 @@
           <a:lstStyle/>
           <a:p>
             <a:pPr>
-              <a:defRPr sz="1000" b="1">
+              <a:defRPr sz="1050" b="1">
                 <a:solidFill>
                   <a:srgbClr val="FF8C69"/>
                 </a:solidFill>
@@ -9455,7 +9532,7 @@
               </a:defRPr>
             </a:pPr>
             <a:r>
-              <a:t>WhatsApp bot · Exchanges · Multi-seller auth · Audio analysis · Public cloud deployment</a:t>
+              <a:t>Advanced video forensics (Case D stretch) · WhatsApp bot · Exchanges · Multi-seller auth · Audio analysis · Public cloud deployment</a:t>
             </a:r>
           </a:p>
         </p:txBody>
@@ -9468,8 +9545,8 @@
         </p:nvSpPr>
         <p:spPr>
           <a:xfrm>
-            <a:off x="8961120" y="5257800"/>
-            <a:ext cx="2651760" cy="777240"/>
+            <a:off x="8961120" y="5184648"/>
+            <a:ext cx="2651760" cy="914400"/>
           </a:xfrm>
           <a:prstGeom prst="rect">
             <a:avLst/>
@@ -9483,7 +9560,7 @@
           <a:lstStyle/>
           <a:p>
             <a:pPr>
-              <a:defRPr sz="1000" b="1">
+              <a:defRPr sz="1050" b="1">
                 <a:solidFill>
                   <a:srgbClr val="00D1A7"/>
                 </a:solidFill>
@@ -9496,7 +9573,7 @@
           </a:p>
           <a:p>
             <a:pPr>
-              <a:defRPr sz="1100">
+              <a:defRPr sz="1150">
                 <a:solidFill>
                   <a:srgbClr val="FFFFFF"/>
                 </a:solidFill>

</xml_diff>

<commit_message>
feat(v5): resolve PPTX card empty space, repeat Case C termination on Slide 4, align Slide 6 notes, and expand smoke test suite
</commit_message>
<xml_diff>
--- a/ReturnLens_v5.pptx
+++ b/ReturnLens_v5.pptx
@@ -1072,32 +1072,32 @@
           </a:p>
           <a:p>
             <a:r>
-              <a:t>     - Person A (Agent / Backend / Policy / Authorization): LangGraph orchestrator, mock store/courier APIs, order status fast path, deterministic rules P-01 to P-08, fail-closed authorization gate.</a:t>
-            </a:r>
-          </a:p>
-          <a:p>
-            <a:r>
-              <a:t>     - Person B (Vision / Evidence / UI): FFmpeg keyframe extraction, vision schema, critic prompt, seller console UI.</a:t>
-            </a:r>
-          </a:p>
-          <a:p>
-            <a:r>
-              <a:t>     - Person C (Mock Fixtures / Integration / QA): Test fixtures, clarification/resume loop, 4 staged demo cases (A-D), authorization tests, demo video recording, README.</a:t>
-            </a:r>
-          </a:p>
-          <a:p>
-            <a:r>
-              <a:t>  3. Strict Scope Discipline:</a:t>
-            </a:r>
-          </a:p>
-          <a:p>
-            <a:r>
-              <a:t>     - MUST DELIVER: Mock store/courier APIs, deterministic policy engine, frame citations, seller authorization gate, structured audit log, clarification/resume loop, 4 demo cases.</a:t>
-            </a:r>
-          </a:p>
-          <a:p>
-            <a:r>
-              <a:t>     - CUT FIRST IF BEHIND: Case D advanced continuity checks (stretch), real carrier webhooks, multi-product order parsing, video OCR barcode scanning, production payment gateways, seller analytics dashboards.</a:t>
+              <a:t>     - Person A (Backend / Policy / Authorization): LangGraph orchestrator, mock store &amp; courier APIs, order status fast path, deterministic rules P-01 to P-08, fail-closed authorization gate, approval binding (case ID + evidence hash + policy version).</a:t>
+            </a:r>
+          </a:p>
+          <a:p>
+            <a:r>
+              <a:t>     - Person B (Vision / Evidence / UI): FFmpeg keyframe pipeline (~1fps sampling), vision schema, critic prompt, interactive 1-click seller console UI with mock evidence pack.</a:t>
+            </a:r>
+          </a:p>
+          <a:p>
+            <a:r>
+              <a:t>     - Person C (Integration / Scenarios / QA): Test fixtures for 3 core demo cases (A–C) + Case D sequence test, Case C clarification/resume lifecycle, fail-closed human gate testing, demo video recording, README.</a:t>
+            </a:r>
+          </a:p>
+          <a:p>
+            <a:r>
+              <a:t>  3. Strict Scope Discipline (matching slide face):</a:t>
+            </a:r>
+          </a:p>
+          <a:p>
+            <a:r>
+              <a:t>     - MUST DELIVER: Mock store &amp; courier APIs, deterministic policy engine &amp; seller gate, Case B color contradiction &amp; Case C re-film loop, 3 core demo cases (A–C) + Case D sequence test, approval binding (case + evidence hash + policy version), structured JSON audit trail &amp; order-status fast path.</a:t>
+            </a:r>
+          </a:p>
+          <a:p>
+            <a:r>
+              <a:t>     - CUT FIRST IF BEHIND: Advanced video forensic splice analysis (Case D stretch), WhatsApp bot, exchanges, multi-seller auth, audio analysis, public cloud deployment.</a:t>
             </a:r>
           </a:p>
           <a:p>
@@ -4286,7 +4286,7 @@
         <p:spPr>
           <a:xfrm>
             <a:off x="4754880" y="777240"/>
-            <a:ext cx="7013448" cy="5349240"/>
+            <a:ext cx="7013448" cy="4526280"/>
           </a:xfrm>
           <a:prstGeom prst="roundRect">
             <a:avLst/>
@@ -4331,7 +4331,7 @@
         <p:spPr>
           <a:xfrm>
             <a:off x="4754880" y="777240"/>
-            <a:ext cx="7013448" cy="475488"/>
+            <a:ext cx="7013448" cy="438912"/>
           </a:xfrm>
           <a:prstGeom prst="rect">
             <a:avLst/>
@@ -4371,7 +4371,7 @@
         </p:nvSpPr>
         <p:spPr>
           <a:xfrm>
-            <a:off x="4937760" y="850392"/>
+            <a:off x="4937760" y="832104"/>
             <a:ext cx="6647688" cy="329184"/>
           </a:xfrm>
           <a:prstGeom prst="rect">
@@ -4386,7 +4386,7 @@
           <a:lstStyle/>
           <a:p>
             <a:pPr>
-              <a:defRPr sz="1050" b="1">
+              <a:defRPr sz="1000" b="1">
                 <a:solidFill>
                   <a:srgbClr val="FDF2D0"/>
                 </a:solidFill>
@@ -4407,8 +4407,8 @@
         </p:nvSpPr>
         <p:spPr>
           <a:xfrm>
-            <a:off x="4754880" y="1252728"/>
-            <a:ext cx="7013448" cy="384048"/>
+            <a:off x="4754880" y="1216152"/>
+            <a:ext cx="7013448" cy="347472"/>
           </a:xfrm>
           <a:prstGeom prst="rect">
             <a:avLst/>
@@ -4452,8 +4452,8 @@
         </p:nvSpPr>
         <p:spPr>
           <a:xfrm>
-            <a:off x="4937760" y="1289304"/>
-            <a:ext cx="6647688" cy="292608"/>
+            <a:off x="4937760" y="1252728"/>
+            <a:ext cx="6647688" cy="274320"/>
           </a:xfrm>
           <a:prstGeom prst="rect">
             <a:avLst/>
@@ -4467,7 +4467,7 @@
           <a:lstStyle/>
           <a:p>
             <a:pPr>
-              <a:defRPr sz="1000">
+              <a:defRPr sz="950">
                 <a:solidFill>
                   <a:srgbClr val="14241E"/>
                 </a:solidFill>
@@ -4488,8 +4488,8 @@
         </p:nvSpPr>
         <p:spPr>
           <a:xfrm>
-            <a:off x="4937760" y="1783080"/>
-            <a:ext cx="3246120" cy="2194560"/>
+            <a:off x="4937760" y="1655064"/>
+            <a:ext cx="3246120" cy="2011680"/>
           </a:xfrm>
           <a:prstGeom prst="roundRect">
             <a:avLst/>
@@ -4533,8 +4533,8 @@
         </p:nvSpPr>
         <p:spPr>
           <a:xfrm>
-            <a:off x="5074920" y="1965960"/>
-            <a:ext cx="2971800" cy="1920240"/>
+            <a:off x="5047488" y="1746504"/>
+            <a:ext cx="3026664" cy="1847088"/>
           </a:xfrm>
           <a:prstGeom prst="rect">
             <a:avLst/>
@@ -4548,7 +4548,7 @@
           <a:lstStyle/>
           <a:p>
             <a:pPr>
-              <a:defRPr sz="950" b="1">
+              <a:defRPr sz="900" b="1">
                 <a:solidFill>
                   <a:srgbClr val="5C7066"/>
                 </a:solidFill>
@@ -4561,7 +4561,7 @@
           </a:p>
           <a:p>
             <a:pPr>
-              <a:defRPr sz="1600" b="1">
+              <a:defRPr sz="1500" b="1">
                 <a:solidFill>
                   <a:srgbClr val="14241E"/>
                 </a:solidFill>
@@ -4574,7 +4574,7 @@
           </a:p>
           <a:p>
             <a:pPr>
-              <a:defRPr sz="1100">
+              <a:defRPr sz="1000">
                 <a:solidFill>
                   <a:srgbClr val="5C7066"/>
                 </a:solidFill>
@@ -4590,7 +4590,11 @@
             </a:r>
             <a:br/>
             <a:r>
-              <a:t>Status: Verified against order</a:t>
+              <a:t>Delivered: 4d ago (Shippo #SH-9012)</a:t>
+            </a:r>
+            <a:br/>
+            <a:r>
+              <a:t>Return Window: Day 4/7 (P-04 PASS)</a:t>
             </a:r>
           </a:p>
         </p:txBody>
@@ -4603,8 +4607,8 @@
         </p:nvSpPr>
         <p:spPr>
           <a:xfrm>
-            <a:off x="8339328" y="1783080"/>
-            <a:ext cx="3246120" cy="2194560"/>
+            <a:off x="8339328" y="1655064"/>
+            <a:ext cx="3246120" cy="2011680"/>
           </a:xfrm>
           <a:prstGeom prst="roundRect">
             <a:avLst/>
@@ -4648,8 +4652,8 @@
         </p:nvSpPr>
         <p:spPr>
           <a:xfrm>
-            <a:off x="8476488" y="1965960"/>
-            <a:ext cx="2971800" cy="1920240"/>
+            <a:off x="8449056" y="1746504"/>
+            <a:ext cx="3026664" cy="1847088"/>
           </a:xfrm>
           <a:prstGeom prst="rect">
             <a:avLst/>
@@ -4663,7 +4667,7 @@
           <a:lstStyle/>
           <a:p>
             <a:pPr>
-              <a:defRPr sz="950" b="1">
+              <a:defRPr sz="900" b="1">
                 <a:solidFill>
                   <a:srgbClr val="C0392B"/>
                 </a:solidFill>
@@ -4689,7 +4693,7 @@
           </a:p>
           <a:p>
             <a:pPr>
-              <a:defRPr sz="1100">
+              <a:defRPr sz="1000">
                 <a:solidFill>
                   <a:srgbClr val="243830"/>
                 </a:solidFill>
@@ -4705,7 +4709,11 @@
             </a:r>
             <a:br/>
             <a:r>
-              <a:t>Lighting: Optimal (142/255)</a:t>
+              <a:t>Lighting: Optimal (142/255) · 1080p</a:t>
+            </a:r>
+            <a:br/>
+            <a:r>
+              <a:t>Policy Check: P-03 Color Match FAIL</a:t>
             </a:r>
           </a:p>
         </p:txBody>
@@ -4718,8 +4726,8 @@
         </p:nvSpPr>
         <p:spPr>
           <a:xfrm>
-            <a:off x="4937760" y="4160520"/>
-            <a:ext cx="6647688" cy="685800"/>
+            <a:off x="4937760" y="3758184"/>
+            <a:ext cx="6647688" cy="493776"/>
           </a:xfrm>
           <a:prstGeom prst="roundRect">
             <a:avLst/>
@@ -4763,8 +4771,8 @@
         </p:nvSpPr>
         <p:spPr>
           <a:xfrm>
-            <a:off x="5074920" y="4270248"/>
-            <a:ext cx="6373368" cy="457200"/>
+            <a:off x="5047488" y="3831336"/>
+            <a:ext cx="6428232" cy="384048"/>
           </a:xfrm>
           <a:prstGeom prst="rect">
             <a:avLst/>
@@ -4778,7 +4786,7 @@
           <a:lstStyle/>
           <a:p>
             <a:pPr>
-              <a:defRPr sz="1050" b="1">
+              <a:defRPr sz="1000" b="1">
                 <a:solidFill>
                   <a:srgbClr val="962D22"/>
                 </a:solidFill>
@@ -4793,14 +4801,59 @@
       </p:sp>
       <p:sp>
         <p:nvSpPr>
-          <p:cNvPr id="16" name="TextBox 15"/>
+          <p:cNvPr id="16" name="Rounded Rectangle 15"/>
+          <p:cNvSpPr/>
+          <p:nvPr/>
+        </p:nvSpPr>
+        <p:spPr>
+          <a:xfrm>
+            <a:off x="4937760" y="4325112"/>
+            <a:ext cx="6647688" cy="329184"/>
+          </a:xfrm>
+          <a:prstGeom prst="roundRect">
+            <a:avLst/>
+          </a:prstGeom>
+          <a:solidFill>
+            <a:srgbClr val="F2EFEB"/>
+          </a:solidFill>
+          <a:ln w="12700">
+            <a:solidFill>
+              <a:srgbClr val="E3DDD4"/>
+            </a:solidFill>
+          </a:ln>
+        </p:spPr>
+        <p:style>
+          <a:lnRef idx="1">
+            <a:schemeClr val="accent1"/>
+          </a:lnRef>
+          <a:fillRef idx="3">
+            <a:schemeClr val="accent1"/>
+          </a:fillRef>
+          <a:effectRef idx="2">
+            <a:schemeClr val="accent1"/>
+          </a:effectRef>
+          <a:fontRef idx="minor">
+            <a:schemeClr val="lt1"/>
+          </a:fontRef>
+        </p:style>
+        <p:txBody>
+          <a:bodyPr rtlCol="0" anchor="ctr"/>
+          <a:lstStyle/>
+          <a:p>
+            <a:pPr algn="ctr"/>
+          </a:p>
+        </p:txBody>
+      </p:sp>
+      <p:sp>
+        <p:nvSpPr>
+          <p:cNvPr id="17" name="TextBox 16"/>
           <p:cNvSpPr txBox="1"/>
           <p:nvPr/>
         </p:nvSpPr>
         <p:spPr>
           <a:xfrm>
-            <a:off x="4937760" y="5001768"/>
-            <a:ext cx="2926080" cy="365760"/>
+            <a:off x="5047488" y="4379976"/>
+            <a:ext cx="6428232" cy="237744"/>
           </a:xfrm>
           <a:prstGeom prst="rect">
             <a:avLst/>
@@ -4814,7 +4867,43 @@
           <a:lstStyle/>
           <a:p>
             <a:pPr>
-              <a:defRPr sz="1000" b="1">
+              <a:defRPr sz="850">
+                <a:solidFill>
+                  <a:srgbClr val="5C7066"/>
+                </a:solidFill>
+                <a:latin typeface="IBM Plex Mono"/>
+              </a:defRPr>
+            </a:pPr>
+            <a:r>
+              <a:t>AUDIT LEDGER: Logged to SQLite · SHA256:7f8a2c · Server refund cap: ≤ min(₹4,999, rem, paid)</a:t>
+            </a:r>
+          </a:p>
+        </p:txBody>
+      </p:sp>
+      <p:sp>
+        <p:nvSpPr>
+          <p:cNvPr id="18" name="TextBox 17"/>
+          <p:cNvSpPr txBox="1"/>
+          <p:nvPr/>
+        </p:nvSpPr>
+        <p:spPr>
+          <a:xfrm>
+            <a:off x="4937760" y="4782312"/>
+            <a:ext cx="2926080" cy="329184"/>
+          </a:xfrm>
+          <a:prstGeom prst="rect">
+            <a:avLst/>
+          </a:prstGeom>
+          <a:noFill/>
+        </p:spPr>
+        <p:txBody>
+          <a:bodyPr wrap="none">
+            <a:spAutoFit/>
+          </a:bodyPr>
+          <a:lstStyle/>
+          <a:p>
+            <a:pPr>
+              <a:defRPr sz="950" b="1">
                 <a:solidFill>
                   <a:srgbClr val="92400E"/>
                 </a:solidFill>
@@ -4829,14 +4918,14 @@
       </p:sp>
       <p:sp>
         <p:nvSpPr>
-          <p:cNvPr id="17" name="Rounded Rectangle 16"/>
+          <p:cNvPr id="19" name="Rounded Rectangle 18"/>
           <p:cNvSpPr/>
           <p:nvPr/>
         </p:nvSpPr>
         <p:spPr>
           <a:xfrm>
-            <a:off x="7909560" y="4956048"/>
-            <a:ext cx="1691640" cy="411480"/>
+            <a:off x="7909560" y="4745736"/>
+            <a:ext cx="1691640" cy="347472"/>
           </a:xfrm>
           <a:prstGeom prst="roundRect">
             <a:avLst/>
@@ -4869,7 +4958,7 @@
           <a:lstStyle/>
           <a:p>
             <a:pPr algn="ctr">
-              <a:defRPr sz="1000" b="1">
+              <a:defRPr sz="950" b="1">
                 <a:solidFill>
                   <a:srgbClr val="14241E"/>
                 </a:solidFill>
@@ -4884,14 +4973,14 @@
       </p:sp>
       <p:sp>
         <p:nvSpPr>
-          <p:cNvPr id="18" name="Rounded Rectangle 17"/>
+          <p:cNvPr id="20" name="Rounded Rectangle 19"/>
           <p:cNvSpPr/>
           <p:nvPr/>
         </p:nvSpPr>
         <p:spPr>
           <a:xfrm>
-            <a:off x="9692640" y="4956048"/>
-            <a:ext cx="1874519" cy="411480"/>
+            <a:off x="9692640" y="4745736"/>
+            <a:ext cx="1874519" cy="347472"/>
           </a:xfrm>
           <a:prstGeom prst="roundRect">
             <a:avLst/>
@@ -4920,7 +5009,7 @@
           <a:lstStyle/>
           <a:p>
             <a:pPr algn="ctr">
-              <a:defRPr sz="1050" b="1">
+              <a:defRPr sz="1000" b="1">
                 <a:solidFill>
                   <a:srgbClr val="FFFFFF"/>
                 </a:solidFill>
@@ -4935,7 +5024,7 @@
       </p:sp>
       <p:sp>
         <p:nvSpPr>
-          <p:cNvPr id="19" name="Rectangle 18"/>
+          <p:cNvPr id="21" name="Rectangle 20"/>
           <p:cNvSpPr/>
           <p:nvPr/>
         </p:nvSpPr>
@@ -4976,7 +5065,7 @@
       </p:sp>
       <p:sp>
         <p:nvSpPr>
-          <p:cNvPr id="20" name="TextBox 19"/>
+          <p:cNvPr id="22" name="TextBox 21"/>
           <p:cNvSpPr txBox="1"/>
           <p:nvPr/>
         </p:nvSpPr>
@@ -5012,7 +5101,7 @@
       </p:sp>
       <p:sp>
         <p:nvSpPr>
-          <p:cNvPr id="21" name="TextBox 20"/>
+          <p:cNvPr id="23" name="TextBox 22"/>
           <p:cNvSpPr txBox="1"/>
           <p:nvPr/>
         </p:nvSpPr>
@@ -7607,7 +7696,7 @@
             <a:br/>
             <a:br/>
             <a:r>
-              <a:t>Case state saved to WAITING_FOR_EVIDENCE and resumes on upload (1 retry limit).</a:t>
+              <a:t>Case state saved to WAITING_FOR_EVIDENCE and resumes on upload. After 1 retry, escalates with both attempts logged (never auto-denies).</a:t>
             </a:r>
           </a:p>
         </p:txBody>
@@ -8140,8 +8229,8 @@
         </p:nvSpPr>
         <p:spPr>
           <a:xfrm>
-            <a:off x="694944" y="1737360"/>
-            <a:ext cx="4389120" cy="4206240"/>
+            <a:off x="640080" y="1636776"/>
+            <a:ext cx="4498848" cy="676656"/>
           </a:xfrm>
           <a:prstGeom prst="rect">
             <a:avLst/>
@@ -8149,13 +8238,13 @@
           <a:noFill/>
         </p:spPr>
         <p:txBody>
-          <a:bodyPr wrap="square">
+          <a:bodyPr wrap="square" lIns="0" tIns="0" rIns="0" bIns="0">
             <a:spAutoFit/>
           </a:bodyPr>
           <a:lstStyle/>
           <a:p>
             <a:pPr>
-              <a:defRPr sz="1100" b="1">
+              <a:defRPr sz="1000" b="1">
                 <a:solidFill>
                   <a:srgbClr val="C0392B"/>
                 </a:solidFill>
@@ -8163,15 +8252,12 @@
               </a:defRPr>
             </a:pPr>
             <a:r>
-              <a:t>CORE BENCHMARK SCENARIO · ESCALATE</a:t>
-            </a:r>
-          </a:p>
-          <a:p>
-            <a:pPr>
-              <a:spcAft>
-                <a:spcPts val="1000"/>
-              </a:spcAft>
-              <a:defRPr sz="2000" b="1">
+              <a:t>CORE BENCHMARK SCENARIO · P-03 CONTRADICTION</a:t>
+            </a:r>
+          </a:p>
+          <a:p>
+            <a:pPr>
+              <a:defRPr sz="1900" b="1">
                 <a:solidFill>
                   <a:srgbClr val="14241E"/>
                 </a:solidFill>
@@ -8184,70 +8270,365 @@
           </a:p>
           <a:p>
             <a:pPr>
-              <a:spcAft>
-                <a:spcPts val="1400"/>
-              </a:spcAft>
-              <a:defRPr sz="1050">
+              <a:defRPr sz="1000">
+                <a:solidFill>
+                  <a:srgbClr val="5C7066"/>
+                </a:solidFill>
+                <a:latin typeface="Inter"/>
+              </a:defRPr>
+            </a:pPr>
+            <a:r>
+              <a:t>The order says White. Unboxing video frame 00:07 shows Black.</a:t>
+            </a:r>
+          </a:p>
+        </p:txBody>
+      </p:sp>
+      <p:sp>
+        <p:nvSpPr>
+          <p:cNvPr id="7" name="Rounded Rectangle 6"/>
+          <p:cNvSpPr/>
+          <p:nvPr/>
+        </p:nvSpPr>
+        <p:spPr>
+          <a:xfrm>
+            <a:off x="640080" y="2386584"/>
+            <a:ext cx="4498848" cy="1371600"/>
+          </a:xfrm>
+          <a:prstGeom prst="roundRect">
+            <a:avLst/>
+          </a:prstGeom>
+          <a:solidFill>
+            <a:srgbClr val="FDF2F2"/>
+          </a:solidFill>
+          <a:ln w="12700">
+            <a:solidFill>
+              <a:srgbClr val="F5B7B1"/>
+            </a:solidFill>
+          </a:ln>
+        </p:spPr>
+        <p:style>
+          <a:lnRef idx="1">
+            <a:schemeClr val="accent1"/>
+          </a:lnRef>
+          <a:fillRef idx="3">
+            <a:schemeClr val="accent1"/>
+          </a:fillRef>
+          <a:effectRef idx="2">
+            <a:schemeClr val="accent1"/>
+          </a:effectRef>
+          <a:fontRef idx="minor">
+            <a:schemeClr val="lt1"/>
+          </a:fontRef>
+        </p:style>
+        <p:txBody>
+          <a:bodyPr rtlCol="0" anchor="ctr"/>
+          <a:lstStyle/>
+          <a:p>
+            <a:pPr algn="ctr"/>
+          </a:p>
+        </p:txBody>
+      </p:sp>
+      <p:sp>
+        <p:nvSpPr>
+          <p:cNvPr id="8" name="TextBox 7"/>
+          <p:cNvSpPr txBox="1"/>
+          <p:nvPr/>
+        </p:nvSpPr>
+        <p:spPr>
+          <a:xfrm>
+            <a:off x="749808" y="2459736"/>
+            <a:ext cx="4279392" cy="1243584"/>
+          </a:xfrm>
+          <a:prstGeom prst="rect">
+            <a:avLst/>
+          </a:prstGeom>
+          <a:noFill/>
+        </p:spPr>
+        <p:txBody>
+          <a:bodyPr wrap="square" lIns="0" tIns="0" rIns="0" bIns="0">
+            <a:spAutoFit/>
+          </a:bodyPr>
+          <a:lstStyle/>
+          <a:p>
+            <a:pPr>
+              <a:defRPr sz="900" b="1">
+                <a:solidFill>
+                  <a:srgbClr val="C0392B"/>
+                </a:solidFill>
+                <a:latin typeface="IBM Plex Mono"/>
+              </a:defRPr>
+            </a:pPr>
+            <a:r>
+              <a:t>MOCK EVIDENCE PACK · KEYFRAME 00:07 CITATION</a:t>
+            </a:r>
+          </a:p>
+          <a:p>
+            <a:pPr>
+              <a:defRPr sz="950">
+                <a:solidFill>
+                  <a:srgbClr val="14241E"/>
+                </a:solidFill>
+                <a:latin typeface="Inter"/>
+              </a:defRPr>
+            </a:pPr>
+            <a:r>
+              <a:t>Manifest Record: HEAD-WHT-02 (Matte White) · ₹1,499 paid · Shippo #SH-9012</a:t>
+            </a:r>
+          </a:p>
+          <a:p>
+            <a:pPr>
+              <a:defRPr sz="1000" b="1">
                 <a:solidFill>
                   <a:srgbClr val="962D22"/>
                 </a:solidFill>
+                <a:latin typeface="Inter"/>
+              </a:defRPr>
+            </a:pPr>
+            <a:r>
+              <a:t>Observed Keyframe: Black casing (color-consistent with HEAD-BLK-09)</a:t>
+            </a:r>
+          </a:p>
+          <a:p>
+            <a:pPr>
+              <a:defRPr sz="850">
+                <a:solidFill>
+                  <a:srgbClr val="5C7066"/>
+                </a:solidFill>
                 <a:latin typeface="IBM Plex Mono"/>
               </a:defRPr>
             </a:pPr>
             <a:r>
-              <a:t>Order Record: HEAD-WHT-02 (White, ₹1,499)</a:t>
-            </a:r>
-            <a:br/>
-            <a:r>
-              <a:t>Observed Frame 00:07: Black casing</a:t>
-            </a:r>
-            <a:br/>
-            <a:r>
-              <a:t>Color Match: Consistent with HEAD-BLK-09</a:t>
-            </a:r>
-            <a:br/>
-            <a:r>
-              <a:t>Barcode: Unverified (SKU not verified)</a:t>
-            </a:r>
-            <a:br/>
-            <a:r>
-              <a:t>Policy Evaluation: P-03 Color Match: FAIL</a:t>
-            </a:r>
-            <a:br/>
-            <a:r>
-              <a:t>Automated Action: No label · No refund draft · No denial</a:t>
-            </a:r>
-          </a:p>
-          <a:p>
-            <a:pPr>
-              <a:defRPr sz="1150">
-                <a:solidFill>
-                  <a:srgbClr val="243830"/>
+              <a:t>Barcode / SKU: Unverified · Optimal Lighting (142/255) · REC 00:07 / 00:24</a:t>
+            </a:r>
+          </a:p>
+          <a:p>
+            <a:pPr>
+              <a:defRPr sz="950" b="1">
+                <a:solidFill>
+                  <a:srgbClr val="962D22"/>
                 </a:solidFill>
                 <a:latin typeface="Inter"/>
               </a:defRPr>
             </a:pPr>
             <a:r>
-              <a:t>PRESERVED SELLER OPTIONS IN MOCK EVIDENCE PACK:</a:t>
-            </a:r>
-            <a:br/>
-            <a:r>
-              <a:t>• Accept as warehouse mis-shipment</a:t>
-            </a:r>
-            <a:br/>
-            <a:r>
-              <a:t>• Request customer photo of outer box shipping barcode</a:t>
-            </a:r>
-            <a:br/>
-            <a:r>
-              <a:t>• Hold case for physical receipt inspection at depot</a:t>
-            </a:r>
-          </a:p>
-        </p:txBody>
-      </p:sp>
-      <p:sp>
-        <p:nvSpPr>
-          <p:cNvPr id="7" name="Rounded Rectangle 6"/>
+              <a:t>P-03 Policy Check: FAIL → Blocks automatic approval (no label, no draft)</a:t>
+            </a:r>
+          </a:p>
+        </p:txBody>
+      </p:sp>
+      <p:sp>
+        <p:nvSpPr>
+          <p:cNvPr id="9" name="Rounded Rectangle 8"/>
+          <p:cNvSpPr/>
+          <p:nvPr/>
+        </p:nvSpPr>
+        <p:spPr>
+          <a:xfrm>
+            <a:off x="640080" y="3831336"/>
+            <a:ext cx="4498848" cy="384048"/>
+          </a:xfrm>
+          <a:prstGeom prst="roundRect">
+            <a:avLst/>
+          </a:prstGeom>
+          <a:solidFill>
+            <a:srgbClr val="14241E"/>
+          </a:solidFill>
+          <a:ln/>
+        </p:spPr>
+        <p:style>
+          <a:lnRef idx="1">
+            <a:schemeClr val="accent1"/>
+          </a:lnRef>
+          <a:fillRef idx="3">
+            <a:schemeClr val="accent1"/>
+          </a:fillRef>
+          <a:effectRef idx="2">
+            <a:schemeClr val="accent1"/>
+          </a:effectRef>
+          <a:fontRef idx="minor">
+            <a:schemeClr val="lt1"/>
+          </a:fontRef>
+        </p:style>
+        <p:txBody>
+          <a:bodyPr rtlCol="0" anchor="ctr"/>
+          <a:lstStyle/>
+          <a:p>
+            <a:pPr algn="ctr"/>
+          </a:p>
+        </p:txBody>
+      </p:sp>
+      <p:sp>
+        <p:nvSpPr>
+          <p:cNvPr id="10" name="TextBox 9"/>
+          <p:cNvSpPr txBox="1"/>
+          <p:nvPr/>
+        </p:nvSpPr>
+        <p:spPr>
+          <a:xfrm>
+            <a:off x="749808" y="3904488"/>
+            <a:ext cx="4279392" cy="256032"/>
+          </a:xfrm>
+          <a:prstGeom prst="rect">
+            <a:avLst/>
+          </a:prstGeom>
+          <a:noFill/>
+        </p:spPr>
+        <p:txBody>
+          <a:bodyPr wrap="none" lIns="0" tIns="0">
+            <a:spAutoFit/>
+          </a:bodyPr>
+          <a:lstStyle/>
+          <a:p>
+            <a:pPr>
+              <a:defRPr sz="950" b="1">
+                <a:solidFill>
+                  <a:srgbClr val="FFD485"/>
+                </a:solidFill>
+                <a:latin typeface="IBM Plex Mono"/>
+              </a:defRPr>
+            </a:pPr>
+            <a:r>
+              <a:t>POLICY ACTION: ESCALATE TO SELLER GATE (FAIL-CLOSED)</a:t>
+            </a:r>
+          </a:p>
+        </p:txBody>
+      </p:sp>
+      <p:sp>
+        <p:nvSpPr>
+          <p:cNvPr id="11" name="Rounded Rectangle 10"/>
+          <p:cNvSpPr/>
+          <p:nvPr/>
+        </p:nvSpPr>
+        <p:spPr>
+          <a:xfrm>
+            <a:off x="640080" y="4288536"/>
+            <a:ext cx="4498848" cy="1691640"/>
+          </a:xfrm>
+          <a:prstGeom prst="roundRect">
+            <a:avLst/>
+          </a:prstGeom>
+          <a:solidFill>
+            <a:srgbClr val="F2EFEB"/>
+          </a:solidFill>
+          <a:ln w="12700">
+            <a:solidFill>
+              <a:srgbClr val="E3DDD4"/>
+            </a:solidFill>
+          </a:ln>
+        </p:spPr>
+        <p:style>
+          <a:lnRef idx="1">
+            <a:schemeClr val="accent1"/>
+          </a:lnRef>
+          <a:fillRef idx="3">
+            <a:schemeClr val="accent1"/>
+          </a:fillRef>
+          <a:effectRef idx="2">
+            <a:schemeClr val="accent1"/>
+          </a:effectRef>
+          <a:fontRef idx="minor">
+            <a:schemeClr val="lt1"/>
+          </a:fontRef>
+        </p:style>
+        <p:txBody>
+          <a:bodyPr rtlCol="0" anchor="ctr"/>
+          <a:lstStyle/>
+          <a:p>
+            <a:pPr algn="ctr"/>
+          </a:p>
+        </p:txBody>
+      </p:sp>
+      <p:sp>
+        <p:nvSpPr>
+          <p:cNvPr id="12" name="TextBox 11"/>
+          <p:cNvSpPr txBox="1"/>
+          <p:nvPr/>
+        </p:nvSpPr>
+        <p:spPr>
+          <a:xfrm>
+            <a:off x="749808" y="4379976"/>
+            <a:ext cx="4279392" cy="1545336"/>
+          </a:xfrm>
+          <a:prstGeom prst="rect">
+            <a:avLst/>
+          </a:prstGeom>
+          <a:noFill/>
+        </p:spPr>
+        <p:txBody>
+          <a:bodyPr wrap="square" lIns="0" tIns="0" rIns="0" bIns="0">
+            <a:spAutoFit/>
+          </a:bodyPr>
+          <a:lstStyle/>
+          <a:p>
+            <a:pPr>
+              <a:defRPr sz="900" b="1">
+                <a:solidFill>
+                  <a:srgbClr val="004D3C"/>
+                </a:solidFill>
+                <a:latin typeface="IBM Plex Mono"/>
+              </a:defRPr>
+            </a:pPr>
+            <a:r>
+              <a:t>PRESERVED SELLER OPTIONS IN DECISION CONSOLE:</a:t>
+            </a:r>
+          </a:p>
+          <a:p>
+            <a:pPr>
+              <a:defRPr sz="950">
+                <a:solidFill>
+                  <a:srgbClr val="14241E"/>
+                </a:solidFill>
+                <a:latin typeface="Inter"/>
+              </a:defRPr>
+            </a:pPr>
+            <a:r>
+              <a:t>① Accept as warehouse mis-shipment (seller acknowledges error)</a:t>
+            </a:r>
+          </a:p>
+          <a:p>
+            <a:pPr>
+              <a:defRPr sz="950">
+                <a:solidFill>
+                  <a:srgbClr val="14241E"/>
+                </a:solidFill>
+                <a:latin typeface="Inter"/>
+              </a:defRPr>
+            </a:pPr>
+            <a:r>
+              <a:t>② Request customer photo of outer box shipping barcode</a:t>
+            </a:r>
+          </a:p>
+          <a:p>
+            <a:pPr>
+              <a:defRPr sz="950">
+                <a:solidFill>
+                  <a:srgbClr val="14241E"/>
+                </a:solidFill>
+                <a:latin typeface="Inter"/>
+              </a:defRPr>
+            </a:pPr>
+            <a:r>
+              <a:t>③ Hold case for physical parcel inspection at returns depot</a:t>
+            </a:r>
+          </a:p>
+          <a:p>
+            <a:pPr>
+              <a:defRPr sz="850">
+                <a:solidFill>
+                  <a:srgbClr val="5C7066"/>
+                </a:solidFill>
+                <a:latin typeface="IBM Plex Mono"/>
+              </a:defRPr>
+            </a:pPr>
+            <a:r>
+              <a:t>Financial Guardrail: 0 &lt; amount ≤ min(₹4,999, rem, paid) · Binds evidence hash</a:t>
+            </a:r>
+          </a:p>
+        </p:txBody>
+      </p:sp>
+      <p:sp>
+        <p:nvSpPr>
+          <p:cNvPr id="13" name="Rounded Rectangle 12"/>
           <p:cNvSpPr/>
           <p:nvPr/>
         </p:nvSpPr>
@@ -8292,7 +8673,7 @@
       </p:sp>
       <p:sp>
         <p:nvSpPr>
-          <p:cNvPr id="8" name="TextBox 7"/>
+          <p:cNvPr id="14" name="TextBox 13"/>
           <p:cNvSpPr txBox="1"/>
           <p:nvPr/>
         </p:nvSpPr>
@@ -8354,7 +8735,7 @@
       </p:sp>
       <p:sp>
         <p:nvSpPr>
-          <p:cNvPr id="9" name="Rounded Rectangle 8"/>
+          <p:cNvPr id="15" name="Rounded Rectangle 14"/>
           <p:cNvSpPr/>
           <p:nvPr/>
         </p:nvSpPr>
@@ -8399,7 +8780,7 @@
       </p:sp>
       <p:sp>
         <p:nvSpPr>
-          <p:cNvPr id="10" name="TextBox 9"/>
+          <p:cNvPr id="16" name="TextBox 15"/>
           <p:cNvSpPr txBox="1"/>
           <p:nvPr/>
         </p:nvSpPr>
@@ -8461,7 +8842,7 @@
       </p:sp>
       <p:sp>
         <p:nvSpPr>
-          <p:cNvPr id="11" name="Rounded Rectangle 10"/>
+          <p:cNvPr id="17" name="Rounded Rectangle 16"/>
           <p:cNvSpPr/>
           <p:nvPr/>
         </p:nvSpPr>
@@ -8506,7 +8887,7 @@
       </p:sp>
       <p:sp>
         <p:nvSpPr>
-          <p:cNvPr id="12" name="TextBox 11"/>
+          <p:cNvPr id="18" name="TextBox 17"/>
           <p:cNvSpPr txBox="1"/>
           <p:nvPr/>
         </p:nvSpPr>
@@ -8568,7 +8949,7 @@
       </p:sp>
       <p:sp>
         <p:nvSpPr>
-          <p:cNvPr id="13" name="Rectangle 12"/>
+          <p:cNvPr id="19" name="Rectangle 18"/>
           <p:cNvSpPr/>
           <p:nvPr/>
         </p:nvSpPr>
@@ -8609,7 +8990,7 @@
       </p:sp>
       <p:sp>
         <p:nvSpPr>
-          <p:cNvPr id="14" name="TextBox 13"/>
+          <p:cNvPr id="20" name="TextBox 19"/>
           <p:cNvSpPr txBox="1"/>
           <p:nvPr/>
         </p:nvSpPr>
@@ -8645,7 +9026,7 @@
       </p:sp>
       <p:sp>
         <p:nvSpPr>
-          <p:cNvPr id="15" name="TextBox 14"/>
+          <p:cNvPr id="21" name="TextBox 20"/>
           <p:cNvSpPr txBox="1"/>
           <p:nvPr/>
         </p:nvSpPr>
@@ -9121,8 +9502,8 @@
         </p:nvSpPr>
         <p:spPr>
           <a:xfrm>
-            <a:off x="603504" y="2953512"/>
-            <a:ext cx="3246120" cy="1828800"/>
+            <a:off x="585216" y="2916936"/>
+            <a:ext cx="3282696" cy="1929384"/>
           </a:xfrm>
           <a:prstGeom prst="rect">
             <a:avLst/>
@@ -9130,13 +9511,13 @@
           <a:noFill/>
         </p:spPr>
         <p:txBody>
-          <a:bodyPr wrap="square">
+          <a:bodyPr wrap="square" lIns="0" tIns="0" rIns="0" bIns="0">
             <a:spAutoFit/>
           </a:bodyPr>
           <a:lstStyle/>
           <a:p>
             <a:pPr>
-              <a:defRPr sz="1100" b="1">
+              <a:defRPr sz="950" b="1">
                 <a:solidFill>
                   <a:srgbClr val="006B54"/>
                 </a:solidFill>
@@ -9144,36 +9525,100 @@
               </a:defRPr>
             </a:pPr>
             <a:r>
-              <a:t>PERSON A</a:t>
+              <a:t>PERSON A · BACKEND, POLICY &amp; AUDIT</a:t>
+            </a:r>
+          </a:p>
+          <a:p>
+            <a:pPr>
+              <a:defRPr sz="1300" b="1">
+                <a:solidFill>
+                  <a:srgbClr val="14241E"/>
+                </a:solidFill>
+                <a:latin typeface="Inter"/>
+              </a:defRPr>
+            </a:pPr>
+            <a:r>
+              <a:t>State Machine &amp; Policy Engine</a:t>
             </a:r>
           </a:p>
           <a:p>
             <a:pPr>
               <a:spcAft>
-                <a:spcPts val="800"/>
+                <a:spcPts val="400"/>
               </a:spcAft>
-              <a:defRPr sz="1400" b="1">
-                <a:solidFill>
-                  <a:srgbClr val="14241E"/>
+              <a:defRPr sz="850">
+                <a:solidFill>
+                  <a:srgbClr val="5C7066"/>
+                </a:solidFill>
+                <a:latin typeface="IBM Plex Mono"/>
+              </a:defRPr>
+            </a:pPr>
+            <a:r>
+              <a:t>Stack: LangGraph · Pydantic · SQLite · SHA256</a:t>
+            </a:r>
+          </a:p>
+          <a:p>
+            <a:pPr>
+              <a:spcAft>
+                <a:spcPts val="200"/>
+              </a:spcAft>
+              <a:defRPr sz="950">
+                <a:solidFill>
+                  <a:srgbClr val="243830"/>
                 </a:solidFill>
                 <a:latin typeface="Inter"/>
               </a:defRPr>
             </a:pPr>
             <a:r>
-              <a:t>Backend, Policy &amp; Audit</a:t>
-            </a:r>
-          </a:p>
-          <a:p>
-            <a:pPr>
-              <a:defRPr sz="1100">
-                <a:solidFill>
-                  <a:srgbClr val="5C7066"/>
+              <a:t>• Policy P-01 to P-08: Deterministic code rules (window, SKU, tag, refund cap)</a:t>
+            </a:r>
+          </a:p>
+          <a:p>
+            <a:pPr>
+              <a:spcAft>
+                <a:spcPts val="200"/>
+              </a:spcAft>
+              <a:defRPr sz="950">
+                <a:solidFill>
+                  <a:srgbClr val="243830"/>
                 </a:solidFill>
                 <a:latin typeface="Inter"/>
               </a:defRPr>
             </a:pPr>
             <a:r>
-              <a:t>LangGraph state machine, policy engine P-01 to P-08, Critic validation, append-only JSON audit trail, server-side refund cap calculation.</a:t>
+              <a:t>• Critic Agent: Adversarial check against cited keyframe timestamps</a:t>
+            </a:r>
+          </a:p>
+          <a:p>
+            <a:pPr>
+              <a:spcAft>
+                <a:spcPts val="200"/>
+              </a:spcAft>
+              <a:defRPr sz="950">
+                <a:solidFill>
+                  <a:srgbClr val="243830"/>
+                </a:solidFill>
+                <a:latin typeface="Inter"/>
+              </a:defRPr>
+            </a:pPr>
+            <a:r>
+              <a:t>• Audit Ledger: Append-only JSON log &amp; cryptographic approval binding</a:t>
+            </a:r>
+          </a:p>
+          <a:p>
+            <a:pPr>
+              <a:spcAft>
+                <a:spcPts val="200"/>
+              </a:spcAft>
+              <a:defRPr sz="950">
+                <a:solidFill>
+                  <a:srgbClr val="243830"/>
+                </a:solidFill>
+                <a:latin typeface="Inter"/>
+              </a:defRPr>
+            </a:pPr>
+            <a:r>
+              <a:t>• Financial Cap: Server calculation min(₹4,999, remaining, paid)</a:t>
             </a:r>
           </a:p>
         </p:txBody>
@@ -9231,8 +9676,8 @@
         </p:nvSpPr>
         <p:spPr>
           <a:xfrm>
-            <a:off x="4471416" y="2953512"/>
-            <a:ext cx="3246120" cy="1828800"/>
+            <a:off x="4453128" y="2916936"/>
+            <a:ext cx="3282696" cy="1929384"/>
           </a:xfrm>
           <a:prstGeom prst="rect">
             <a:avLst/>
@@ -9240,13 +9685,13 @@
           <a:noFill/>
         </p:spPr>
         <p:txBody>
-          <a:bodyPr wrap="square">
+          <a:bodyPr wrap="square" lIns="0" tIns="0" rIns="0" bIns="0">
             <a:spAutoFit/>
           </a:bodyPr>
           <a:lstStyle/>
           <a:p>
             <a:pPr>
-              <a:defRPr sz="1100" b="1">
+              <a:defRPr sz="950" b="1">
                 <a:solidFill>
                   <a:srgbClr val="006B54"/>
                 </a:solidFill>
@@ -9254,36 +9699,100 @@
               </a:defRPr>
             </a:pPr>
             <a:r>
-              <a:t>PERSON B</a:t>
+              <a:t>PERSON B · VISION &amp; CONSOLE</a:t>
+            </a:r>
+          </a:p>
+          <a:p>
+            <a:pPr>
+              <a:defRPr sz="1300" b="1">
+                <a:solidFill>
+                  <a:srgbClr val="14241E"/>
+                </a:solidFill>
+                <a:latin typeface="Inter"/>
+              </a:defRPr>
+            </a:pPr>
+            <a:r>
+              <a:t>Video Pipeline &amp; Seller UI</a:t>
             </a:r>
           </a:p>
           <a:p>
             <a:pPr>
               <a:spcAft>
-                <a:spcPts val="800"/>
+                <a:spcPts val="400"/>
               </a:spcAft>
-              <a:defRPr sz="1400" b="1">
-                <a:solidFill>
-                  <a:srgbClr val="14241E"/>
+              <a:defRPr sz="850">
+                <a:solidFill>
+                  <a:srgbClr val="5C7066"/>
+                </a:solidFill>
+                <a:latin typeface="IBM Plex Mono"/>
+              </a:defRPr>
+            </a:pPr>
+            <a:r>
+              <a:t>Stack: FFmpeg · Gemini 2.5 Flash · HTML/CSS/SVG</a:t>
+            </a:r>
+          </a:p>
+          <a:p>
+            <a:pPr>
+              <a:spcAft>
+                <a:spcPts val="200"/>
+              </a:spcAft>
+              <a:defRPr sz="950">
+                <a:solidFill>
+                  <a:srgbClr val="243830"/>
                 </a:solidFill>
                 <a:latin typeface="Inter"/>
               </a:defRPr>
             </a:pPr>
             <a:r>
-              <a:t>Video &amp; Seller Console</a:t>
-            </a:r>
-          </a:p>
-          <a:p>
-            <a:pPr>
-              <a:defRPr sz="1100">
-                <a:solidFill>
-                  <a:srgbClr val="5C7066"/>
+              <a:t>• Keyframe Pipeline: Uniform ~1fps sampling &amp; brightness scoring (avg 28)</a:t>
+            </a:r>
+          </a:p>
+          <a:p>
+            <a:pPr>
+              <a:spcAft>
+                <a:spcPts val="200"/>
+              </a:spcAft>
+              <a:defRPr sz="950">
+                <a:solidFill>
+                  <a:srgbClr val="243830"/>
                 </a:solidFill>
                 <a:latin typeface="Inter"/>
               </a:defRPr>
             </a:pPr>
             <a:r>
-              <a:t>FFmpeg keyframe pipeline (~1fps sampling), vision model structured citation prompt, interactive 1-click Seller Console mockup.</a:t>
+              <a:t>• Structured Vision: Observation schema with timestamp citation metadata</a:t>
+            </a:r>
+          </a:p>
+          <a:p>
+            <a:pPr>
+              <a:spcAft>
+                <a:spcPts val="200"/>
+              </a:spcAft>
+              <a:defRPr sz="950">
+                <a:solidFill>
+                  <a:srgbClr val="243830"/>
+                </a:solidFill>
+                <a:latin typeface="Inter"/>
+              </a:defRPr>
+            </a:pPr>
+            <a:r>
+              <a:t>• Seller Console: 1-click decision console with mock evidence pack</a:t>
+            </a:r>
+          </a:p>
+          <a:p>
+            <a:pPr>
+              <a:spcAft>
+                <a:spcPts val="200"/>
+              </a:spcAft>
+              <a:defRPr sz="950">
+                <a:solidFill>
+                  <a:srgbClr val="243830"/>
+                </a:solidFill>
+                <a:latin typeface="Inter"/>
+              </a:defRPr>
+            </a:pPr>
+            <a:r>
+              <a:t>• Grounding Guard: Enforces unverified barcode vs color distinction</a:t>
             </a:r>
           </a:p>
         </p:txBody>
@@ -9341,8 +9850,8 @@
         </p:nvSpPr>
         <p:spPr>
           <a:xfrm>
-            <a:off x="8339328" y="2953512"/>
-            <a:ext cx="3246120" cy="1828800"/>
+            <a:off x="8321040" y="2916936"/>
+            <a:ext cx="3282696" cy="1929384"/>
           </a:xfrm>
           <a:prstGeom prst="rect">
             <a:avLst/>
@@ -9350,13 +9859,13 @@
           <a:noFill/>
         </p:spPr>
         <p:txBody>
-          <a:bodyPr wrap="square">
+          <a:bodyPr wrap="square" lIns="0" tIns="0" rIns="0" bIns="0">
             <a:spAutoFit/>
           </a:bodyPr>
           <a:lstStyle/>
           <a:p>
             <a:pPr>
-              <a:defRPr sz="1100" b="1">
+              <a:defRPr sz="950" b="1">
                 <a:solidFill>
                   <a:srgbClr val="006B54"/>
                 </a:solidFill>
@@ -9364,36 +9873,100 @@
               </a:defRPr>
             </a:pPr>
             <a:r>
-              <a:t>PERSON C</a:t>
+              <a:t>PERSON C · INTEGRATION &amp; QA</a:t>
+            </a:r>
+          </a:p>
+          <a:p>
+            <a:pPr>
+              <a:defRPr sz="1300" b="1">
+                <a:solidFill>
+                  <a:srgbClr val="14241E"/>
+                </a:solidFill>
+                <a:latin typeface="Inter"/>
+              </a:defRPr>
+            </a:pPr>
+            <a:r>
+              <a:t>Scenarios, Lifecycle &amp; QA</a:t>
             </a:r>
           </a:p>
           <a:p>
             <a:pPr>
               <a:spcAft>
-                <a:spcPts val="800"/>
+                <a:spcPts val="400"/>
               </a:spcAft>
-              <a:defRPr sz="1400" b="1">
-                <a:solidFill>
-                  <a:srgbClr val="14241E"/>
+              <a:defRPr sz="850">
+                <a:solidFill>
+                  <a:srgbClr val="5C7066"/>
+                </a:solidFill>
+                <a:latin typeface="IBM Plex Mono"/>
+              </a:defRPr>
+            </a:pPr>
+            <a:r>
+              <a:t>Stack: Pytest · Mock Fixtures · Automated Smoke QA</a:t>
+            </a:r>
+          </a:p>
+          <a:p>
+            <a:pPr>
+              <a:spcAft>
+                <a:spcPts val="200"/>
+              </a:spcAft>
+              <a:defRPr sz="950">
+                <a:solidFill>
+                  <a:srgbClr val="243830"/>
                 </a:solidFill>
                 <a:latin typeface="Inter"/>
               </a:defRPr>
             </a:pPr>
             <a:r>
-              <a:t>Integration, Scenarios &amp; QA</a:t>
-            </a:r>
-          </a:p>
-          <a:p>
-            <a:pPr>
-              <a:defRPr sz="1100">
-                <a:solidFill>
-                  <a:srgbClr val="5C7066"/>
+              <a:t>• Benchmark Cases: Staged data for Cases A–C + Case D sequence test</a:t>
+            </a:r>
+          </a:p>
+          <a:p>
+            <a:pPr>
+              <a:spcAft>
+                <a:spcPts val="200"/>
+              </a:spcAft>
+              <a:defRPr sz="950">
+                <a:solidFill>
+                  <a:srgbClr val="243830"/>
                 </a:solidFill>
                 <a:latin typeface="Inter"/>
               </a:defRPr>
             </a:pPr>
             <a:r>
-              <a:t>Test fixtures for Cases A–D, Case C pause/resume lifecycle, fail-closed human gate testing, benchmark runner, video capture.</a:t>
+              <a:t>• Case C Lifecycle: Re-film loop in WAITING_FOR_EVIDENCE (1 retry)</a:t>
+            </a:r>
+          </a:p>
+          <a:p>
+            <a:pPr>
+              <a:spcAft>
+                <a:spcPts val="200"/>
+              </a:spcAft>
+              <a:defRPr sz="950">
+                <a:solidFill>
+                  <a:srgbClr val="243830"/>
+                </a:solidFill>
+                <a:latin typeface="Inter"/>
+              </a:defRPr>
+            </a:pPr>
+            <a:r>
+              <a:t>• Fail-Closed Testing: Verifies zero automated refunds &amp; approval gates</a:t>
+            </a:r>
+          </a:p>
+          <a:p>
+            <a:pPr>
+              <a:spcAft>
+                <a:spcPts val="200"/>
+              </a:spcAft>
+              <a:defRPr sz="950">
+                <a:solidFill>
+                  <a:srgbClr val="243830"/>
+                </a:solidFill>
+                <a:latin typeface="Inter"/>
+              </a:defRPr>
+            </a:pPr>
+            <a:r>
+              <a:t>• Automated QA: 9-test smoke runner, end-to-end event bus &amp; demo recording</a:t>
             </a:r>
           </a:p>
         </p:txBody>

</xml_diff>

<commit_message>
feat(v6): create ReturnLens v6 visual redesign edition with rich mock evidence assets and 10/10 QA smoke suite
</commit_message>
<xml_diff>
--- a/ReturnLens_v5.pptx
+++ b/ReturnLens_v5.pptx
@@ -4180,7 +4180,7 @@
                 <a:solidFill>
                   <a:srgbClr val="006B54"/>
                 </a:solidFill>
-                <a:latin typeface="IBM Plex Mono"/>
+                <a:latin typeface="Consolas"/>
               </a:defRPr>
             </a:pPr>
             <a:r>
@@ -4219,7 +4219,7 @@
                 <a:solidFill>
                   <a:srgbClr val="14241E"/>
                 </a:solidFill>
-                <a:latin typeface="Inter"/>
+                <a:latin typeface="Calibri"/>
               </a:defRPr>
             </a:pPr>
             <a:r>
@@ -4235,7 +4235,7 @@
                 <a:solidFill>
                   <a:srgbClr val="006B54"/>
                 </a:solidFill>
-                <a:latin typeface="Inter"/>
+                <a:latin typeface="Calibri"/>
               </a:defRPr>
             </a:pPr>
             <a:r>
@@ -4247,11 +4247,11 @@
               <a:spcAft>
                 <a:spcPts val="2000"/>
               </a:spcAft>
-              <a:defRPr sz="1400">
+              <a:defRPr sz="1500">
                 <a:solidFill>
                   <a:srgbClr val="5C7066"/>
                 </a:solidFill>
-                <a:latin typeface="Inter"/>
+                <a:latin typeface="Calibri"/>
               </a:defRPr>
             </a:pPr>
             <a:r>
@@ -4264,7 +4264,7 @@
                 <a:solidFill>
                   <a:srgbClr val="243830"/>
                 </a:solidFill>
-                <a:latin typeface="IBM Plex Mono"/>
+                <a:latin typeface="Consolas"/>
               </a:defRPr>
             </a:pPr>
             <a:r>
@@ -4390,7 +4390,7 @@
                 <a:solidFill>
                   <a:srgbClr val="FDF2D0"/>
                 </a:solidFill>
-                <a:latin typeface="IBM Plex Mono"/>
+                <a:latin typeface="Consolas"/>
               </a:defRPr>
             </a:pPr>
             <a:r>
@@ -4471,7 +4471,7 @@
                 <a:solidFill>
                   <a:srgbClr val="14241E"/>
                 </a:solidFill>
-                <a:latin typeface="IBM Plex Mono"/>
+                <a:latin typeface="Consolas"/>
               </a:defRPr>
             </a:pPr>
             <a:r>
@@ -4552,7 +4552,7 @@
                 <a:solidFill>
                   <a:srgbClr val="5C7066"/>
                 </a:solidFill>
-                <a:latin typeface="IBM Plex Mono"/>
+                <a:latin typeface="Consolas"/>
               </a:defRPr>
             </a:pPr>
             <a:r>
@@ -4561,11 +4561,11 @@
           </a:p>
           <a:p>
             <a:pPr>
-              <a:defRPr sz="1500" b="1">
+              <a:defRPr sz="1600" b="1">
                 <a:solidFill>
                   <a:srgbClr val="14241E"/>
                 </a:solidFill>
-                <a:latin typeface="Inter"/>
+                <a:latin typeface="Calibri"/>
               </a:defRPr>
             </a:pPr>
             <a:r>
@@ -4574,11 +4574,11 @@
           </a:p>
           <a:p>
             <a:pPr>
-              <a:defRPr sz="1000">
+              <a:defRPr sz="1100">
                 <a:solidFill>
                   <a:srgbClr val="5C7066"/>
                 </a:solidFill>
-                <a:latin typeface="Inter"/>
+                <a:latin typeface="Calibri"/>
               </a:defRPr>
             </a:pPr>
             <a:r>
@@ -4671,7 +4671,7 @@
                 <a:solidFill>
                   <a:srgbClr val="C0392B"/>
                 </a:solidFill>
-                <a:latin typeface="IBM Plex Mono"/>
+                <a:latin typeface="Consolas"/>
               </a:defRPr>
             </a:pPr>
             <a:r>
@@ -4680,11 +4680,11 @@
           </a:p>
           <a:p>
             <a:pPr>
-              <a:defRPr sz="1500" b="1">
+              <a:defRPr sz="1600" b="1">
                 <a:solidFill>
                   <a:srgbClr val="962D22"/>
                 </a:solidFill>
-                <a:latin typeface="Inter"/>
+                <a:latin typeface="Calibri"/>
               </a:defRPr>
             </a:pPr>
             <a:r>
@@ -4693,11 +4693,11 @@
           </a:p>
           <a:p>
             <a:pPr>
-              <a:defRPr sz="1000">
+              <a:defRPr sz="1100">
                 <a:solidFill>
                   <a:srgbClr val="243830"/>
                 </a:solidFill>
-                <a:latin typeface="Inter"/>
+                <a:latin typeface="Calibri"/>
               </a:defRPr>
             </a:pPr>
             <a:r>
@@ -4709,7 +4709,7 @@
             </a:r>
             <a:br/>
             <a:r>
-              <a:t>Lighting: Optimal (142/255) · 1080p</a:t>
+              <a:t>Lighting: Optimal (142/255)</a:t>
             </a:r>
             <a:br/>
             <a:r>
@@ -4790,7 +4790,7 @@
                 <a:solidFill>
                   <a:srgbClr val="962D22"/>
                 </a:solidFill>
-                <a:latin typeface="IBM Plex Mono"/>
+                <a:latin typeface="Consolas"/>
               </a:defRPr>
             </a:pPr>
             <a:r>
@@ -4871,11 +4871,11 @@
                 <a:solidFill>
                   <a:srgbClr val="5C7066"/>
                 </a:solidFill>
-                <a:latin typeface="IBM Plex Mono"/>
-              </a:defRPr>
-            </a:pPr>
-            <a:r>
-              <a:t>AUDIT LEDGER: Logged to SQLite · SHA256:7f8a2c · Server refund cap: ≤ min(₹4,999, rem, paid)</a:t>
+                <a:latin typeface="Consolas"/>
+              </a:defRPr>
+            </a:pPr>
+            <a:r>
+              <a:t>AUDIT LEDGER: Logged to SQLite · SHA256 evidence hash · Server refund cap: ≤ min(₹4,999, rem, paid)</a:t>
             </a:r>
           </a:p>
         </p:txBody>
@@ -4907,7 +4907,7 @@
                 <a:solidFill>
                   <a:srgbClr val="92400E"/>
                 </a:solidFill>
-                <a:latin typeface="IBM Plex Mono"/>
+                <a:latin typeface="Consolas"/>
               </a:defRPr>
             </a:pPr>
             <a:r>
@@ -4958,11 +4958,11 @@
           <a:lstStyle/>
           <a:p>
             <a:pPr algn="ctr">
-              <a:defRPr sz="950" b="1">
+              <a:defRPr sz="1050" b="1">
                 <a:solidFill>
                   <a:srgbClr val="14241E"/>
                 </a:solidFill>
-                <a:latin typeface="Inter"/>
+                <a:latin typeface="Calibri"/>
               </a:defRPr>
             </a:pPr>
             <a:r>
@@ -5009,11 +5009,11 @@
           <a:lstStyle/>
           <a:p>
             <a:pPr algn="ctr">
-              <a:defRPr sz="1000" b="1">
+              <a:defRPr sz="1100" b="1">
                 <a:solidFill>
                   <a:srgbClr val="FFFFFF"/>
                 </a:solidFill>
-                <a:latin typeface="Inter"/>
+                <a:latin typeface="Calibri"/>
               </a:defRPr>
             </a:pPr>
             <a:r>
@@ -5090,7 +5090,7 @@
                 <a:solidFill>
                   <a:srgbClr val="8A9C93"/>
                 </a:solidFill>
-                <a:latin typeface="IBM Plex Mono"/>
+                <a:latin typeface="Consolas"/>
               </a:defRPr>
             </a:pPr>
             <a:r>
@@ -5126,7 +5126,7 @@
                 <a:solidFill>
                   <a:srgbClr val="8A9C93"/>
                 </a:solidFill>
-                <a:latin typeface="IBM Plex Mono"/>
+                <a:latin typeface="Consolas"/>
               </a:defRPr>
             </a:pPr>
             <a:r>
@@ -5225,7 +5225,7 @@
                 <a:solidFill>
                   <a:srgbClr val="006B54"/>
                 </a:solidFill>
-                <a:latin typeface="IBM Plex Mono"/>
+                <a:latin typeface="Consolas"/>
               </a:defRPr>
             </a:pPr>
             <a:r>
@@ -5261,7 +5261,7 @@
                 <a:solidFill>
                   <a:srgbClr val="14241E"/>
                 </a:solidFill>
-                <a:latin typeface="Inter"/>
+                <a:latin typeface="Calibri"/>
               </a:defRPr>
             </a:pPr>
             <a:r>
@@ -5270,11 +5270,11 @@
           </a:p>
           <a:p>
             <a:pPr>
-              <a:defRPr sz="1400">
+              <a:defRPr sz="1500">
                 <a:solidFill>
                   <a:srgbClr val="5C7066"/>
                 </a:solidFill>
-                <a:latin typeface="Inter"/>
+                <a:latin typeface="Calibri"/>
               </a:defRPr>
             </a:pPr>
             <a:r>
@@ -5400,7 +5400,7 @@
                 <a:solidFill>
                   <a:srgbClr val="006B54"/>
                 </a:solidFill>
-                <a:latin typeface="IBM Plex Mono"/>
+                <a:latin typeface="Consolas"/>
               </a:defRPr>
             </a:pPr>
             <a:r>
@@ -5409,11 +5409,11 @@
           </a:p>
           <a:p>
             <a:pPr>
-              <a:defRPr sz="1100">
+              <a:defRPr sz="1200">
                 <a:solidFill>
                   <a:srgbClr val="14241E"/>
                 </a:solidFill>
-                <a:latin typeface="Inter"/>
+                <a:latin typeface="Calibri"/>
               </a:defRPr>
             </a:pPr>
             <a:r>
@@ -5494,7 +5494,7 @@
                 <a:solidFill>
                   <a:srgbClr val="006B54"/>
                 </a:solidFill>
-                <a:latin typeface="IBM Plex Mono"/>
+                <a:latin typeface="Consolas"/>
               </a:defRPr>
             </a:pPr>
             <a:r>
@@ -5503,11 +5503,11 @@
           </a:p>
           <a:p>
             <a:pPr>
-              <a:defRPr sz="1100">
+              <a:defRPr sz="1200">
                 <a:solidFill>
                   <a:srgbClr val="14241E"/>
                 </a:solidFill>
-                <a:latin typeface="Inter"/>
+                <a:latin typeface="Calibri"/>
               </a:defRPr>
             </a:pPr>
             <a:r>
@@ -5588,7 +5588,7 @@
                 <a:solidFill>
                   <a:srgbClr val="006B54"/>
                 </a:solidFill>
-                <a:latin typeface="IBM Plex Mono"/>
+                <a:latin typeface="Consolas"/>
               </a:defRPr>
             </a:pPr>
             <a:r>
@@ -5597,11 +5597,11 @@
           </a:p>
           <a:p>
             <a:pPr>
-              <a:defRPr sz="1100">
+              <a:defRPr sz="1200">
                 <a:solidFill>
                   <a:srgbClr val="14241E"/>
                 </a:solidFill>
-                <a:latin typeface="Inter"/>
+                <a:latin typeface="Calibri"/>
               </a:defRPr>
             </a:pPr>
             <a:r>
@@ -5682,7 +5682,7 @@
                 <a:solidFill>
                   <a:srgbClr val="006B54"/>
                 </a:solidFill>
-                <a:latin typeface="IBM Plex Mono"/>
+                <a:latin typeface="Consolas"/>
               </a:defRPr>
             </a:pPr>
             <a:r>
@@ -5691,11 +5691,11 @@
           </a:p>
           <a:p>
             <a:pPr>
-              <a:defRPr sz="1100">
+              <a:defRPr sz="1200">
                 <a:solidFill>
                   <a:srgbClr val="14241E"/>
                 </a:solidFill>
-                <a:latin typeface="Inter"/>
+                <a:latin typeface="Calibri"/>
               </a:defRPr>
             </a:pPr>
             <a:r>
@@ -5731,7 +5731,7 @@
                 <a:solidFill>
                   <a:srgbClr val="006B54"/>
                 </a:solidFill>
-                <a:latin typeface="Inter"/>
+                <a:latin typeface="Calibri"/>
               </a:defRPr>
             </a:pPr>
             <a:r>
@@ -5811,7 +5811,7 @@
                 <a:solidFill>
                   <a:srgbClr val="FFD485"/>
                 </a:solidFill>
-                <a:latin typeface="IBM Plex Mono"/>
+                <a:latin typeface="Consolas"/>
               </a:defRPr>
             </a:pPr>
             <a:r>
@@ -5827,7 +5827,7 @@
                 <a:solidFill>
                   <a:srgbClr val="FFFFFF"/>
                 </a:solidFill>
-                <a:latin typeface="Inter"/>
+                <a:latin typeface="Calibri"/>
               </a:defRPr>
             </a:pPr>
             <a:r>
@@ -5836,11 +5836,11 @@
           </a:p>
           <a:p>
             <a:pPr>
-              <a:defRPr sz="1300">
+              <a:defRPr sz="1400">
                 <a:solidFill>
                   <a:srgbClr val="B5CCC2"/>
                 </a:solidFill>
-                <a:latin typeface="Inter"/>
+                <a:latin typeface="Calibri"/>
               </a:defRPr>
             </a:pPr>
             <a:r>
@@ -5921,7 +5921,7 @@
                 <a:solidFill>
                   <a:srgbClr val="004D3C"/>
                 </a:solidFill>
-                <a:latin typeface="IBM Plex Mono"/>
+                <a:latin typeface="Consolas"/>
               </a:defRPr>
             </a:pPr>
             <a:r>
@@ -5930,11 +5930,11 @@
           </a:p>
           <a:p>
             <a:pPr>
-              <a:defRPr sz="1050">
+              <a:defRPr sz="1150">
                 <a:solidFill>
                   <a:srgbClr val="243830"/>
                 </a:solidFill>
-                <a:latin typeface="Inter"/>
+                <a:latin typeface="Calibri"/>
               </a:defRPr>
             </a:pPr>
             <a:r>
@@ -6015,7 +6015,7 @@
                 <a:solidFill>
                   <a:srgbClr val="004D3C"/>
                 </a:solidFill>
-                <a:latin typeface="IBM Plex Mono"/>
+                <a:latin typeface="Consolas"/>
               </a:defRPr>
             </a:pPr>
             <a:r>
@@ -6024,11 +6024,11 @@
           </a:p>
           <a:p>
             <a:pPr>
-              <a:defRPr sz="1050">
+              <a:defRPr sz="1150">
                 <a:solidFill>
                   <a:srgbClr val="243830"/>
                 </a:solidFill>
-                <a:latin typeface="Inter"/>
+                <a:latin typeface="Calibri"/>
               </a:defRPr>
             </a:pPr>
             <a:r>
@@ -6105,7 +6105,7 @@
                 <a:solidFill>
                   <a:srgbClr val="8A9C93"/>
                 </a:solidFill>
-                <a:latin typeface="IBM Plex Mono"/>
+                <a:latin typeface="Consolas"/>
               </a:defRPr>
             </a:pPr>
             <a:r>
@@ -6141,7 +6141,7 @@
                 <a:solidFill>
                   <a:srgbClr val="8A9C93"/>
                 </a:solidFill>
-                <a:latin typeface="IBM Plex Mono"/>
+                <a:latin typeface="Consolas"/>
               </a:defRPr>
             </a:pPr>
             <a:r>
@@ -6240,7 +6240,7 @@
                 <a:solidFill>
                   <a:srgbClr val="006B54"/>
                 </a:solidFill>
-                <a:latin typeface="IBM Plex Mono"/>
+                <a:latin typeface="Consolas"/>
               </a:defRPr>
             </a:pPr>
             <a:r>
@@ -6276,7 +6276,7 @@
                 <a:solidFill>
                   <a:srgbClr val="14241E"/>
                 </a:solidFill>
-                <a:latin typeface="Inter"/>
+                <a:latin typeface="Calibri"/>
               </a:defRPr>
             </a:pPr>
             <a:r>
@@ -6285,11 +6285,11 @@
           </a:p>
           <a:p>
             <a:pPr>
-              <a:defRPr sz="1400">
+              <a:defRPr sz="1500">
                 <a:solidFill>
                   <a:srgbClr val="5C7066"/>
                 </a:solidFill>
-                <a:latin typeface="Inter"/>
+                <a:latin typeface="Calibri"/>
               </a:defRPr>
             </a:pPr>
             <a:r>
@@ -6370,7 +6370,7 @@
                 <a:solidFill>
                   <a:srgbClr val="006B54"/>
                 </a:solidFill>
-                <a:latin typeface="IBM Plex Mono"/>
+                <a:latin typeface="Consolas"/>
               </a:defRPr>
             </a:pPr>
             <a:r>
@@ -6447,11 +6447,11 @@
           <a:lstStyle/>
           <a:p>
             <a:pPr algn="ctr">
-              <a:defRPr sz="1400" b="1">
+              <a:defRPr sz="1500" b="1">
                 <a:solidFill>
                   <a:srgbClr val="14241E"/>
                 </a:solidFill>
-                <a:latin typeface="Inter"/>
+                <a:latin typeface="Calibri"/>
               </a:defRPr>
             </a:pPr>
             <a:r>
@@ -6495,7 +6495,7 @@
                 <a:solidFill>
                   <a:srgbClr val="243830"/>
                 </a:solidFill>
-                <a:latin typeface="IBM Plex Mono"/>
+                <a:latin typeface="Consolas"/>
               </a:defRPr>
             </a:pPr>
             <a:r>
@@ -6550,7 +6550,7 @@
                 <a:solidFill>
                   <a:srgbClr val="FFFFFF"/>
                 </a:solidFill>
-                <a:latin typeface="Inter"/>
+                <a:latin typeface="Calibri"/>
               </a:defRPr>
             </a:pPr>
             <a:r>
@@ -6631,7 +6631,7 @@
                 <a:solidFill>
                   <a:srgbClr val="C0392B"/>
                 </a:solidFill>
-                <a:latin typeface="IBM Plex Mono"/>
+                <a:latin typeface="Consolas"/>
               </a:defRPr>
             </a:pPr>
             <a:r>
@@ -6704,11 +6704,11 @@
           <a:lstStyle/>
           <a:p>
             <a:pPr algn="ctr">
-              <a:defRPr sz="1400" b="1">
+              <a:defRPr sz="1500" b="1">
                 <a:solidFill>
                   <a:srgbClr val="F7F5F0"/>
                 </a:solidFill>
-                <a:latin typeface="Inter"/>
+                <a:latin typeface="Calibri"/>
               </a:defRPr>
             </a:pPr>
             <a:r>
@@ -6752,7 +6752,7 @@
                 <a:solidFill>
                   <a:srgbClr val="962D22"/>
                 </a:solidFill>
-                <a:latin typeface="IBM Plex Mono"/>
+                <a:latin typeface="Consolas"/>
               </a:defRPr>
             </a:pPr>
             <a:r>
@@ -6837,7 +6837,7 @@
                 <a:solidFill>
                   <a:srgbClr val="962D22"/>
                 </a:solidFill>
-                <a:latin typeface="IBM Plex Mono"/>
+                <a:latin typeface="Consolas"/>
               </a:defRPr>
             </a:pPr>
             <a:r>
@@ -6846,15 +6846,15 @@
           </a:p>
           <a:p>
             <a:pPr>
-              <a:defRPr sz="1150">
+              <a:defRPr sz="1250">
                 <a:solidFill>
                   <a:srgbClr val="243830"/>
                 </a:solidFill>
-                <a:latin typeface="Inter"/>
-              </a:defRPr>
-            </a:pPr>
-            <a:r>
-              <a:t>3 Preserved Seller Actions: (1) Accept as warehouse mis-shipment · (2) Request photo of outside-box shipping label · (3) Hold return for physical parcel inspection.</a:t>
+                <a:latin typeface="Calibri"/>
+              </a:defRPr>
+            </a:pPr>
+            <a:r>
+              <a:t>3 Preserved Seller Actions: (1) Accept mis-shipment · (2) Request box-label photo · (3) Hold for inspection.</a:t>
             </a:r>
             <a:br/>
             <a:r>
@@ -6931,7 +6931,7 @@
                 <a:solidFill>
                   <a:srgbClr val="8A9C93"/>
                 </a:solidFill>
-                <a:latin typeface="IBM Plex Mono"/>
+                <a:latin typeface="Consolas"/>
               </a:defRPr>
             </a:pPr>
             <a:r>
@@ -6967,7 +6967,7 @@
                 <a:solidFill>
                   <a:srgbClr val="8A9C93"/>
                 </a:solidFill>
-                <a:latin typeface="IBM Plex Mono"/>
+                <a:latin typeface="Consolas"/>
               </a:defRPr>
             </a:pPr>
             <a:r>
@@ -7066,7 +7066,7 @@
                 <a:solidFill>
                   <a:srgbClr val="00D1A7"/>
                 </a:solidFill>
-                <a:latin typeface="IBM Plex Mono"/>
+                <a:latin typeface="Consolas"/>
               </a:defRPr>
             </a:pPr>
             <a:r>
@@ -7102,7 +7102,7 @@
                 <a:solidFill>
                   <a:srgbClr val="F7F5F0"/>
                 </a:solidFill>
-                <a:latin typeface="Inter"/>
+                <a:latin typeface="Calibri"/>
               </a:defRPr>
             </a:pPr>
             <a:r>
@@ -7111,11 +7111,11 @@
           </a:p>
           <a:p>
             <a:pPr>
-              <a:defRPr sz="1400">
+              <a:defRPr sz="1500">
                 <a:solidFill>
                   <a:srgbClr val="8EABA0"/>
                 </a:solidFill>
-                <a:latin typeface="Inter"/>
+                <a:latin typeface="Calibri"/>
               </a:defRPr>
             </a:pPr>
             <a:r>
@@ -7196,7 +7196,7 @@
                 <a:solidFill>
                   <a:srgbClr val="F7F5F0"/>
                 </a:solidFill>
-                <a:latin typeface="IBM Plex Mono"/>
+                <a:latin typeface="Consolas"/>
               </a:defRPr>
             </a:pPr>
             <a:r>
@@ -7205,11 +7205,11 @@
           </a:p>
           <a:p>
             <a:pPr>
-              <a:defRPr sz="1000">
+              <a:defRPr sz="1100">
                 <a:solidFill>
                   <a:srgbClr val="8EABA0"/>
                 </a:solidFill>
-                <a:latin typeface="Inter"/>
+                <a:latin typeface="Calibri"/>
               </a:defRPr>
             </a:pPr>
             <a:r>
@@ -7245,7 +7245,7 @@
                 <a:solidFill>
                   <a:srgbClr val="F7F5F0"/>
                 </a:solidFill>
-                <a:latin typeface="IBM Plex Mono"/>
+                <a:latin typeface="Consolas"/>
               </a:defRPr>
             </a:pPr>
             <a:r>
@@ -7254,11 +7254,11 @@
           </a:p>
           <a:p>
             <a:pPr>
-              <a:defRPr sz="1000">
+              <a:defRPr sz="1100">
                 <a:solidFill>
                   <a:srgbClr val="8EABA0"/>
                 </a:solidFill>
-                <a:latin typeface="Inter"/>
+                <a:latin typeface="Calibri"/>
               </a:defRPr>
             </a:pPr>
             <a:r>
@@ -7294,7 +7294,7 @@
                 <a:solidFill>
                   <a:srgbClr val="F7F5F0"/>
                 </a:solidFill>
-                <a:latin typeface="IBM Plex Mono"/>
+                <a:latin typeface="Consolas"/>
               </a:defRPr>
             </a:pPr>
             <a:r>
@@ -7303,11 +7303,11 @@
           </a:p>
           <a:p>
             <a:pPr>
-              <a:defRPr sz="1000">
+              <a:defRPr sz="1100">
                 <a:solidFill>
                   <a:srgbClr val="8EABA0"/>
                 </a:solidFill>
-                <a:latin typeface="Inter"/>
+                <a:latin typeface="Calibri"/>
               </a:defRPr>
             </a:pPr>
             <a:r>
@@ -7343,7 +7343,7 @@
                 <a:solidFill>
                   <a:srgbClr val="F7F5F0"/>
                 </a:solidFill>
-                <a:latin typeface="IBM Plex Mono"/>
+                <a:latin typeface="Consolas"/>
               </a:defRPr>
             </a:pPr>
             <a:r>
@@ -7352,11 +7352,11 @@
           </a:p>
           <a:p>
             <a:pPr>
-              <a:defRPr sz="1000">
+              <a:defRPr sz="1100">
                 <a:solidFill>
                   <a:srgbClr val="8EABA0"/>
                 </a:solidFill>
-                <a:latin typeface="Inter"/>
+                <a:latin typeface="Calibri"/>
               </a:defRPr>
             </a:pPr>
             <a:r>
@@ -7392,7 +7392,7 @@
                 <a:solidFill>
                   <a:srgbClr val="00D1A7"/>
                 </a:solidFill>
-                <a:latin typeface="IBM Plex Mono"/>
+                <a:latin typeface="Consolas"/>
               </a:defRPr>
             </a:pPr>
             <a:r>
@@ -7401,11 +7401,11 @@
           </a:p>
           <a:p>
             <a:pPr>
-              <a:defRPr sz="1000">
+              <a:defRPr sz="1100">
                 <a:solidFill>
                   <a:srgbClr val="8EABA0"/>
                 </a:solidFill>
-                <a:latin typeface="Inter"/>
+                <a:latin typeface="Calibri"/>
               </a:defRPr>
             </a:pPr>
             <a:r>
@@ -7441,7 +7441,7 @@
                 <a:solidFill>
                   <a:srgbClr val="F7F5F0"/>
                 </a:solidFill>
-                <a:latin typeface="IBM Plex Mono"/>
+                <a:latin typeface="Consolas"/>
               </a:defRPr>
             </a:pPr>
             <a:r>
@@ -7450,11 +7450,11 @@
           </a:p>
           <a:p>
             <a:pPr>
-              <a:defRPr sz="1000">
+              <a:defRPr sz="1100">
                 <a:solidFill>
                   <a:srgbClr val="8EABA0"/>
                 </a:solidFill>
-                <a:latin typeface="Inter"/>
+                <a:latin typeface="Calibri"/>
               </a:defRPr>
             </a:pPr>
             <a:r>
@@ -7535,7 +7535,7 @@
                 <a:solidFill>
                   <a:srgbClr val="00D1A7"/>
                 </a:solidFill>
-                <a:latin typeface="IBM Plex Mono"/>
+                <a:latin typeface="Consolas"/>
               </a:defRPr>
             </a:pPr>
             <a:r>
@@ -7547,11 +7547,11 @@
               <a:spcAft>
                 <a:spcPts val="800"/>
               </a:spcAft>
-              <a:defRPr sz="1600" b="1">
+              <a:defRPr sz="1700" b="1">
                 <a:solidFill>
                   <a:srgbClr val="F7F5F0"/>
                 </a:solidFill>
-                <a:latin typeface="Inter"/>
+                <a:latin typeface="Calibri"/>
               </a:defRPr>
             </a:pPr>
             <a:r>
@@ -7560,11 +7560,11 @@
           </a:p>
           <a:p>
             <a:pPr>
-              <a:defRPr sz="1100">
+              <a:defRPr sz="1200">
                 <a:solidFill>
                   <a:srgbClr val="8EABA0"/>
                 </a:solidFill>
-                <a:latin typeface="Inter"/>
+                <a:latin typeface="Calibri"/>
               </a:defRPr>
             </a:pPr>
             <a:r>
@@ -7658,7 +7658,7 @@
                 <a:solidFill>
                   <a:srgbClr val="00D1A7"/>
                 </a:solidFill>
-                <a:latin typeface="IBM Plex Mono"/>
+                <a:latin typeface="Consolas"/>
               </a:defRPr>
             </a:pPr>
             <a:r>
@@ -7670,11 +7670,11 @@
               <a:spcAft>
                 <a:spcPts val="800"/>
               </a:spcAft>
-              <a:defRPr sz="1600" b="1">
+              <a:defRPr sz="1700" b="1">
                 <a:solidFill>
                   <a:srgbClr val="F7F5F0"/>
                 </a:solidFill>
-                <a:latin typeface="Inter"/>
+                <a:latin typeface="Calibri"/>
               </a:defRPr>
             </a:pPr>
             <a:r>
@@ -7683,11 +7683,11 @@
           </a:p>
           <a:p>
             <a:pPr>
-              <a:defRPr sz="1100">
+              <a:defRPr sz="1200">
                 <a:solidFill>
                   <a:srgbClr val="8EABA0"/>
                 </a:solidFill>
-                <a:latin typeface="Inter"/>
+                <a:latin typeface="Calibri"/>
               </a:defRPr>
             </a:pPr>
             <a:r>
@@ -7696,7 +7696,7 @@
             <a:br/>
             <a:br/>
             <a:r>
-              <a:t>Case state saved to WAITING_FOR_EVIDENCE and resumes on upload. After 1 retry, escalates with both attempts logged (never auto-denies).</a:t>
+              <a:t>Case state saved to WAITING_FOR_EVIDENCE and resumes on upload. After 1 retry, escalates to seller with both attempts logged (never auto-denies).</a:t>
             </a:r>
           </a:p>
         </p:txBody>
@@ -7773,7 +7773,7 @@
                 <a:solidFill>
                   <a:srgbClr val="00D1A7"/>
                 </a:solidFill>
-                <a:latin typeface="IBM Plex Mono"/>
+                <a:latin typeface="Consolas"/>
               </a:defRPr>
             </a:pPr>
             <a:r>
@@ -7785,11 +7785,11 @@
               <a:spcAft>
                 <a:spcPts val="800"/>
               </a:spcAft>
-              <a:defRPr sz="1600" b="1">
+              <a:defRPr sz="1700" b="1">
                 <a:solidFill>
                   <a:srgbClr val="F7F5F0"/>
                 </a:solidFill>
-                <a:latin typeface="Inter"/>
+                <a:latin typeface="Calibri"/>
               </a:defRPr>
             </a:pPr>
             <a:r>
@@ -7798,11 +7798,11 @@
           </a:p>
           <a:p>
             <a:pPr>
-              <a:defRPr sz="1100">
+              <a:defRPr sz="1200">
                 <a:solidFill>
                   <a:srgbClr val="8EABA0"/>
                 </a:solidFill>
-                <a:latin typeface="Inter"/>
+                <a:latin typeface="Calibri"/>
               </a:defRPr>
             </a:pPr>
             <a:r>
@@ -7893,7 +7893,7 @@
                 <a:solidFill>
                   <a:srgbClr val="FFD485"/>
                 </a:solidFill>
-                <a:latin typeface="IBM Plex Mono"/>
+                <a:latin typeface="Consolas"/>
               </a:defRPr>
             </a:pPr>
             <a:r>
@@ -7906,7 +7906,7 @@
                 <a:solidFill>
                   <a:srgbClr val="8EABA0"/>
                 </a:solidFill>
-                <a:latin typeface="IBM Plex Mono"/>
+                <a:latin typeface="Consolas"/>
               </a:defRPr>
             </a:pPr>
             <a:r>
@@ -7983,7 +7983,7 @@
                 <a:solidFill>
                   <a:srgbClr val="8EABA0"/>
                 </a:solidFill>
-                <a:latin typeface="IBM Plex Mono"/>
+                <a:latin typeface="Consolas"/>
               </a:defRPr>
             </a:pPr>
             <a:r>
@@ -8019,7 +8019,7 @@
                 <a:solidFill>
                   <a:srgbClr val="8EABA0"/>
                 </a:solidFill>
-                <a:latin typeface="IBM Plex Mono"/>
+                <a:latin typeface="Consolas"/>
               </a:defRPr>
             </a:pPr>
             <a:r>
@@ -8118,7 +8118,7 @@
                 <a:solidFill>
                   <a:srgbClr val="006B54"/>
                 </a:solidFill>
-                <a:latin typeface="IBM Plex Mono"/>
+                <a:latin typeface="Consolas"/>
               </a:defRPr>
             </a:pPr>
             <a:r>
@@ -8154,7 +8154,7 @@
                 <a:solidFill>
                   <a:srgbClr val="14241E"/>
                 </a:solidFill>
-                <a:latin typeface="Inter"/>
+                <a:latin typeface="Calibri"/>
               </a:defRPr>
             </a:pPr>
             <a:r>
@@ -8163,11 +8163,11 @@
           </a:p>
           <a:p>
             <a:pPr>
-              <a:defRPr sz="1400">
+              <a:defRPr sz="1500">
                 <a:solidFill>
                   <a:srgbClr val="5C7066"/>
                 </a:solidFill>
-                <a:latin typeface="Inter"/>
+                <a:latin typeface="Calibri"/>
               </a:defRPr>
             </a:pPr>
             <a:r>
@@ -8229,7 +8229,7 @@
         </p:nvSpPr>
         <p:spPr>
           <a:xfrm>
-            <a:off x="640080" y="1636776"/>
+            <a:off x="640080" y="1691640"/>
             <a:ext cx="4498848" cy="676656"/>
           </a:xfrm>
           <a:prstGeom prst="rect">
@@ -8248,7 +8248,7 @@
                 <a:solidFill>
                   <a:srgbClr val="C0392B"/>
                 </a:solidFill>
-                <a:latin typeface="IBM Plex Mono"/>
+                <a:latin typeface="Consolas"/>
               </a:defRPr>
             </a:pPr>
             <a:r>
@@ -8261,7 +8261,7 @@
                 <a:solidFill>
                   <a:srgbClr val="14241E"/>
                 </a:solidFill>
-                <a:latin typeface="Inter"/>
+                <a:latin typeface="Calibri"/>
               </a:defRPr>
             </a:pPr>
             <a:r>
@@ -8270,11 +8270,11 @@
           </a:p>
           <a:p>
             <a:pPr>
-              <a:defRPr sz="1000">
+              <a:defRPr sz="1100">
                 <a:solidFill>
                   <a:srgbClr val="5C7066"/>
                 </a:solidFill>
-                <a:latin typeface="Inter"/>
+                <a:latin typeface="Calibri"/>
               </a:defRPr>
             </a:pPr>
             <a:r>
@@ -8355,7 +8355,7 @@
                 <a:solidFill>
                   <a:srgbClr val="C0392B"/>
                 </a:solidFill>
-                <a:latin typeface="IBM Plex Mono"/>
+                <a:latin typeface="Consolas"/>
               </a:defRPr>
             </a:pPr>
             <a:r>
@@ -8364,28 +8364,28 @@
           </a:p>
           <a:p>
             <a:pPr>
-              <a:defRPr sz="950">
+              <a:defRPr sz="1050">
                 <a:solidFill>
                   <a:srgbClr val="14241E"/>
                 </a:solidFill>
-                <a:latin typeface="Inter"/>
-              </a:defRPr>
-            </a:pPr>
-            <a:r>
-              <a:t>Manifest Record: HEAD-WHT-02 (Matte White) · ₹1,499 paid · Shippo #SH-9012</a:t>
-            </a:r>
-          </a:p>
-          <a:p>
-            <a:pPr>
-              <a:defRPr sz="1000" b="1">
+                <a:latin typeface="Calibri"/>
+              </a:defRPr>
+            </a:pPr>
+            <a:r>
+              <a:t>Manifest: HEAD-WHT-02 White · ₹1,499 · Shippo #SH-9012</a:t>
+            </a:r>
+          </a:p>
+          <a:p>
+            <a:pPr>
+              <a:defRPr sz="1100" b="1">
                 <a:solidFill>
                   <a:srgbClr val="962D22"/>
                 </a:solidFill>
-                <a:latin typeface="Inter"/>
-              </a:defRPr>
-            </a:pPr>
-            <a:r>
-              <a:t>Observed Keyframe: Black casing (color-consistent with HEAD-BLK-09)</a:t>
+                <a:latin typeface="Calibri"/>
+              </a:defRPr>
+            </a:pPr>
+            <a:r>
+              <a:t>Observed: Black casing · color-consistent HEAD-BLK-09</a:t>
             </a:r>
           </a:p>
           <a:p>
@@ -8394,7 +8394,7 @@
                 <a:solidFill>
                   <a:srgbClr val="5C7066"/>
                 </a:solidFill>
-                <a:latin typeface="IBM Plex Mono"/>
+                <a:latin typeface="Consolas"/>
               </a:defRPr>
             </a:pPr>
             <a:r>
@@ -8403,15 +8403,15 @@
           </a:p>
           <a:p>
             <a:pPr>
-              <a:defRPr sz="950" b="1">
+              <a:defRPr sz="1050" b="1">
                 <a:solidFill>
                   <a:srgbClr val="962D22"/>
                 </a:solidFill>
-                <a:latin typeface="Inter"/>
-              </a:defRPr>
-            </a:pPr>
-            <a:r>
-              <a:t>P-03 Policy Check: FAIL → Blocks automatic approval (no label, no draft)</a:t>
+                <a:latin typeface="Calibri"/>
+              </a:defRPr>
+            </a:pPr>
+            <a:r>
+              <a:t>P-03 FAIL → No label, no draft</a:t>
             </a:r>
           </a:p>
         </p:txBody>
@@ -8484,7 +8484,7 @@
                 <a:solidFill>
                   <a:srgbClr val="FFD485"/>
                 </a:solidFill>
-                <a:latin typeface="IBM Plex Mono"/>
+                <a:latin typeface="Consolas"/>
               </a:defRPr>
             </a:pPr>
             <a:r>
@@ -8565,7 +8565,7 @@
                 <a:solidFill>
                   <a:srgbClr val="004D3C"/>
                 </a:solidFill>
-                <a:latin typeface="IBM Plex Mono"/>
+                <a:latin typeface="Consolas"/>
               </a:defRPr>
             </a:pPr>
             <a:r>
@@ -8574,41 +8574,41 @@
           </a:p>
           <a:p>
             <a:pPr>
-              <a:defRPr sz="950">
+              <a:defRPr sz="1050">
                 <a:solidFill>
                   <a:srgbClr val="14241E"/>
                 </a:solidFill>
-                <a:latin typeface="Inter"/>
-              </a:defRPr>
-            </a:pPr>
-            <a:r>
-              <a:t>① Accept as warehouse mis-shipment (seller acknowledges error)</a:t>
-            </a:r>
-          </a:p>
-          <a:p>
-            <a:pPr>
-              <a:defRPr sz="950">
+                <a:latin typeface="Calibri"/>
+              </a:defRPr>
+            </a:pPr>
+            <a:r>
+              <a:t>① Accept warehouse mis-shipment</a:t>
+            </a:r>
+          </a:p>
+          <a:p>
+            <a:pPr>
+              <a:defRPr sz="1050">
                 <a:solidFill>
                   <a:srgbClr val="14241E"/>
                 </a:solidFill>
-                <a:latin typeface="Inter"/>
-              </a:defRPr>
-            </a:pPr>
-            <a:r>
-              <a:t>② Request customer photo of outer box shipping barcode</a:t>
-            </a:r>
-          </a:p>
-          <a:p>
-            <a:pPr>
-              <a:defRPr sz="950">
+                <a:latin typeface="Calibri"/>
+              </a:defRPr>
+            </a:pPr>
+            <a:r>
+              <a:t>② Request outer-box barcode photo</a:t>
+            </a:r>
+          </a:p>
+          <a:p>
+            <a:pPr>
+              <a:defRPr sz="1050">
                 <a:solidFill>
                   <a:srgbClr val="14241E"/>
                 </a:solidFill>
-                <a:latin typeface="Inter"/>
-              </a:defRPr>
-            </a:pPr>
-            <a:r>
-              <a:t>③ Hold case for physical parcel inspection at returns depot</a:t>
+                <a:latin typeface="Calibri"/>
+              </a:defRPr>
+            </a:pPr>
+            <a:r>
+              <a:t>③ Hold for physical parcel inspection</a:t>
             </a:r>
           </a:p>
           <a:p>
@@ -8617,7 +8617,7 @@
                 <a:solidFill>
                   <a:srgbClr val="5C7066"/>
                 </a:solidFill>
-                <a:latin typeface="IBM Plex Mono"/>
+                <a:latin typeface="Consolas"/>
               </a:defRPr>
             </a:pPr>
             <a:r>
@@ -8694,11 +8694,11 @@
           <a:lstStyle/>
           <a:p>
             <a:pPr>
-              <a:defRPr sz="1300" b="1">
+              <a:defRPr sz="1400" b="1">
                 <a:solidFill>
                   <a:srgbClr val="004D3C"/>
                 </a:solidFill>
-                <a:latin typeface="Inter"/>
+                <a:latin typeface="Calibri"/>
               </a:defRPr>
             </a:pPr>
             <a:r>
@@ -8707,11 +8707,11 @@
           </a:p>
           <a:p>
             <a:pPr>
-              <a:defRPr sz="1050">
+              <a:defRPr sz="1150">
                 <a:solidFill>
                   <a:srgbClr val="5C7066"/>
                 </a:solidFill>
-                <a:latin typeface="Inter"/>
+                <a:latin typeface="Calibri"/>
               </a:defRPr>
             </a:pPr>
             <a:r>
@@ -8724,7 +8724,7 @@
                 <a:solidFill>
                   <a:srgbClr val="004D3C"/>
                 </a:solidFill>
-                <a:latin typeface="IBM Plex Mono"/>
+                <a:latin typeface="Consolas"/>
               </a:defRPr>
             </a:pPr>
             <a:r>
@@ -8801,11 +8801,11 @@
           <a:lstStyle/>
           <a:p>
             <a:pPr>
-              <a:defRPr sz="1300" b="1">
+              <a:defRPr sz="1400" b="1">
                 <a:solidFill>
                   <a:srgbClr val="92400E"/>
                 </a:solidFill>
-                <a:latin typeface="Inter"/>
+                <a:latin typeface="Calibri"/>
               </a:defRPr>
             </a:pPr>
             <a:r>
@@ -8814,11 +8814,11 @@
           </a:p>
           <a:p>
             <a:pPr>
-              <a:defRPr sz="1050">
+              <a:defRPr sz="1150">
                 <a:solidFill>
                   <a:srgbClr val="5C7066"/>
                 </a:solidFill>
-                <a:latin typeface="Inter"/>
+                <a:latin typeface="Calibri"/>
               </a:defRPr>
             </a:pPr>
             <a:r>
@@ -8831,7 +8831,7 @@
                 <a:solidFill>
                   <a:srgbClr val="004D3C"/>
                 </a:solidFill>
-                <a:latin typeface="IBM Plex Mono"/>
+                <a:latin typeface="Consolas"/>
               </a:defRPr>
             </a:pPr>
             <a:r>
@@ -8908,11 +8908,11 @@
           <a:lstStyle/>
           <a:p>
             <a:pPr>
-              <a:defRPr sz="1300" b="1">
+              <a:defRPr sz="1400" b="1">
                 <a:solidFill>
                   <a:srgbClr val="14241E"/>
                 </a:solidFill>
-                <a:latin typeface="Inter"/>
+                <a:latin typeface="Calibri"/>
               </a:defRPr>
             </a:pPr>
             <a:r>
@@ -8921,11 +8921,11 @@
           </a:p>
           <a:p>
             <a:pPr>
-              <a:defRPr sz="1050">
+              <a:defRPr sz="1150">
                 <a:solidFill>
                   <a:srgbClr val="5C7066"/>
                 </a:solidFill>
-                <a:latin typeface="Inter"/>
+                <a:latin typeface="Calibri"/>
               </a:defRPr>
             </a:pPr>
             <a:r>
@@ -8938,7 +8938,7 @@
                 <a:solidFill>
                   <a:srgbClr val="004D3C"/>
                 </a:solidFill>
-                <a:latin typeface="IBM Plex Mono"/>
+                <a:latin typeface="Consolas"/>
               </a:defRPr>
             </a:pPr>
             <a:r>
@@ -9015,7 +9015,7 @@
                 <a:solidFill>
                   <a:srgbClr val="8A9C93"/>
                 </a:solidFill>
-                <a:latin typeface="IBM Plex Mono"/>
+                <a:latin typeface="Consolas"/>
               </a:defRPr>
             </a:pPr>
             <a:r>
@@ -9051,7 +9051,7 @@
                 <a:solidFill>
                   <a:srgbClr val="8A9C93"/>
                 </a:solidFill>
-                <a:latin typeface="IBM Plex Mono"/>
+                <a:latin typeface="Consolas"/>
               </a:defRPr>
             </a:pPr>
             <a:r>
@@ -9150,7 +9150,7 @@
                 <a:solidFill>
                   <a:srgbClr val="006B54"/>
                 </a:solidFill>
-                <a:latin typeface="IBM Plex Mono"/>
+                <a:latin typeface="Consolas"/>
               </a:defRPr>
             </a:pPr>
             <a:r>
@@ -9186,7 +9186,7 @@
                 <a:solidFill>
                   <a:srgbClr val="14241E"/>
                 </a:solidFill>
-                <a:latin typeface="Inter"/>
+                <a:latin typeface="Calibri"/>
               </a:defRPr>
             </a:pPr>
             <a:r>
@@ -9195,11 +9195,11 @@
           </a:p>
           <a:p>
             <a:pPr>
-              <a:defRPr sz="1400">
+              <a:defRPr sz="1500">
                 <a:solidFill>
                   <a:srgbClr val="5C7066"/>
                 </a:solidFill>
-                <a:latin typeface="Inter"/>
+                <a:latin typeface="Calibri"/>
               </a:defRPr>
             </a:pPr>
             <a:r>
@@ -9280,7 +9280,7 @@
                 <a:solidFill>
                   <a:srgbClr val="006B54"/>
                 </a:solidFill>
-                <a:latin typeface="IBM Plex Mono"/>
+                <a:latin typeface="Consolas"/>
               </a:defRPr>
             </a:pPr>
             <a:r>
@@ -9289,11 +9289,11 @@
           </a:p>
           <a:p>
             <a:pPr>
-              <a:defRPr sz="950">
+              <a:defRPr sz="1050">
                 <a:solidFill>
                   <a:srgbClr val="5C7066"/>
                 </a:solidFill>
-                <a:latin typeface="Inter"/>
+                <a:latin typeface="Calibri"/>
               </a:defRPr>
             </a:pPr>
             <a:r>
@@ -9329,7 +9329,7 @@
                 <a:solidFill>
                   <a:srgbClr val="006B54"/>
                 </a:solidFill>
-                <a:latin typeface="IBM Plex Mono"/>
+                <a:latin typeface="Consolas"/>
               </a:defRPr>
             </a:pPr>
             <a:r>
@@ -9338,11 +9338,11 @@
           </a:p>
           <a:p>
             <a:pPr>
-              <a:defRPr sz="950">
+              <a:defRPr sz="1050">
                 <a:solidFill>
                   <a:srgbClr val="5C7066"/>
                 </a:solidFill>
-                <a:latin typeface="Inter"/>
+                <a:latin typeface="Calibri"/>
               </a:defRPr>
             </a:pPr>
             <a:r>
@@ -9378,7 +9378,7 @@
                 <a:solidFill>
                   <a:srgbClr val="006B54"/>
                 </a:solidFill>
-                <a:latin typeface="IBM Plex Mono"/>
+                <a:latin typeface="Consolas"/>
               </a:defRPr>
             </a:pPr>
             <a:r>
@@ -9387,11 +9387,11 @@
           </a:p>
           <a:p>
             <a:pPr>
-              <a:defRPr sz="950">
+              <a:defRPr sz="1050">
                 <a:solidFill>
                   <a:srgbClr val="5C7066"/>
                 </a:solidFill>
-                <a:latin typeface="Inter"/>
+                <a:latin typeface="Calibri"/>
               </a:defRPr>
             </a:pPr>
             <a:r>
@@ -9427,7 +9427,7 @@
                 <a:solidFill>
                   <a:srgbClr val="006B54"/>
                 </a:solidFill>
-                <a:latin typeface="IBM Plex Mono"/>
+                <a:latin typeface="Consolas"/>
               </a:defRPr>
             </a:pPr>
             <a:r>
@@ -9436,11 +9436,11 @@
           </a:p>
           <a:p>
             <a:pPr>
-              <a:defRPr sz="950">
+              <a:defRPr sz="1050">
                 <a:solidFill>
                   <a:srgbClr val="5C7066"/>
                 </a:solidFill>
-                <a:latin typeface="Inter"/>
+                <a:latin typeface="Calibri"/>
               </a:defRPr>
             </a:pPr>
             <a:r>
@@ -9458,7 +9458,7 @@
         <p:spPr>
           <a:xfrm>
             <a:off x="420624" y="2788920"/>
-            <a:ext cx="3611880" cy="2148840"/>
+            <a:ext cx="3611880" cy="2240280"/>
           </a:xfrm>
           <a:prstGeom prst="roundRect">
             <a:avLst/>
@@ -9503,7 +9503,7 @@
         <p:spPr>
           <a:xfrm>
             <a:off x="585216" y="2916936"/>
-            <a:ext cx="3282696" cy="1929384"/>
+            <a:ext cx="3282696" cy="2020824"/>
           </a:xfrm>
           <a:prstGeom prst="rect">
             <a:avLst/>
@@ -9521,7 +9521,7 @@
                 <a:solidFill>
                   <a:srgbClr val="006B54"/>
                 </a:solidFill>
-                <a:latin typeface="IBM Plex Mono"/>
+                <a:latin typeface="Consolas"/>
               </a:defRPr>
             </a:pPr>
             <a:r>
@@ -9530,11 +9530,11 @@
           </a:p>
           <a:p>
             <a:pPr>
-              <a:defRPr sz="1300" b="1">
+              <a:defRPr sz="1400" b="1">
                 <a:solidFill>
                   <a:srgbClr val="14241E"/>
                 </a:solidFill>
-                <a:latin typeface="Inter"/>
+                <a:latin typeface="Calibri"/>
               </a:defRPr>
             </a:pPr>
             <a:r>
@@ -9550,7 +9550,7 @@
                 <a:solidFill>
                   <a:srgbClr val="5C7066"/>
                 </a:solidFill>
-                <a:latin typeface="IBM Plex Mono"/>
+                <a:latin typeface="Consolas"/>
               </a:defRPr>
             </a:pPr>
             <a:r>
@@ -9562,11 +9562,11 @@
               <a:spcAft>
                 <a:spcPts val="200"/>
               </a:spcAft>
-              <a:defRPr sz="950">
+              <a:defRPr sz="1050">
                 <a:solidFill>
                   <a:srgbClr val="243830"/>
                 </a:solidFill>
-                <a:latin typeface="Inter"/>
+                <a:latin typeface="Calibri"/>
               </a:defRPr>
             </a:pPr>
             <a:r>
@@ -9578,11 +9578,11 @@
               <a:spcAft>
                 <a:spcPts val="200"/>
               </a:spcAft>
-              <a:defRPr sz="950">
+              <a:defRPr sz="1050">
                 <a:solidFill>
                   <a:srgbClr val="243830"/>
                 </a:solidFill>
-                <a:latin typeface="Inter"/>
+                <a:latin typeface="Calibri"/>
               </a:defRPr>
             </a:pPr>
             <a:r>
@@ -9594,11 +9594,11 @@
               <a:spcAft>
                 <a:spcPts val="200"/>
               </a:spcAft>
-              <a:defRPr sz="950">
+              <a:defRPr sz="1050">
                 <a:solidFill>
                   <a:srgbClr val="243830"/>
                 </a:solidFill>
-                <a:latin typeface="Inter"/>
+                <a:latin typeface="Calibri"/>
               </a:defRPr>
             </a:pPr>
             <a:r>
@@ -9610,11 +9610,11 @@
               <a:spcAft>
                 <a:spcPts val="200"/>
               </a:spcAft>
-              <a:defRPr sz="950">
+              <a:defRPr sz="1050">
                 <a:solidFill>
                   <a:srgbClr val="243830"/>
                 </a:solidFill>
-                <a:latin typeface="Inter"/>
+                <a:latin typeface="Calibri"/>
               </a:defRPr>
             </a:pPr>
             <a:r>
@@ -9632,7 +9632,7 @@
         <p:spPr>
           <a:xfrm>
             <a:off x="4288536" y="2788920"/>
-            <a:ext cx="3611880" cy="2148840"/>
+            <a:ext cx="3611880" cy="2240280"/>
           </a:xfrm>
           <a:prstGeom prst="roundRect">
             <a:avLst/>
@@ -9677,7 +9677,7 @@
         <p:spPr>
           <a:xfrm>
             <a:off x="4453128" y="2916936"/>
-            <a:ext cx="3282696" cy="1929384"/>
+            <a:ext cx="3282696" cy="2020824"/>
           </a:xfrm>
           <a:prstGeom prst="rect">
             <a:avLst/>
@@ -9695,7 +9695,7 @@
                 <a:solidFill>
                   <a:srgbClr val="006B54"/>
                 </a:solidFill>
-                <a:latin typeface="IBM Plex Mono"/>
+                <a:latin typeface="Consolas"/>
               </a:defRPr>
             </a:pPr>
             <a:r>
@@ -9704,11 +9704,11 @@
           </a:p>
           <a:p>
             <a:pPr>
-              <a:defRPr sz="1300" b="1">
+              <a:defRPr sz="1400" b="1">
                 <a:solidFill>
                   <a:srgbClr val="14241E"/>
                 </a:solidFill>
-                <a:latin typeface="Inter"/>
+                <a:latin typeface="Calibri"/>
               </a:defRPr>
             </a:pPr>
             <a:r>
@@ -9724,11 +9724,11 @@
                 <a:solidFill>
                   <a:srgbClr val="5C7066"/>
                 </a:solidFill>
-                <a:latin typeface="IBM Plex Mono"/>
-              </a:defRPr>
-            </a:pPr>
-            <a:r>
-              <a:t>Stack: FFmpeg · Gemini 2.5 Flash · HTML/CSS/SVG</a:t>
+                <a:latin typeface="Consolas"/>
+              </a:defRPr>
+            </a:pPr>
+            <a:r>
+              <a:t>Stack: FFmpeg · Hosted vision model (unpinned) · HTML/CSS/SVG</a:t>
             </a:r>
           </a:p>
           <a:p>
@@ -9736,15 +9736,15 @@
               <a:spcAft>
                 <a:spcPts val="200"/>
               </a:spcAft>
-              <a:defRPr sz="950">
+              <a:defRPr sz="1050">
                 <a:solidFill>
                   <a:srgbClr val="243830"/>
                 </a:solidFill>
-                <a:latin typeface="Inter"/>
-              </a:defRPr>
-            </a:pPr>
-            <a:r>
-              <a:t>• Keyframe Pipeline: Uniform ~1fps sampling &amp; brightness scoring (avg 28)</a:t>
+                <a:latin typeface="Calibri"/>
+              </a:defRPr>
+            </a:pPr>
+            <a:r>
+              <a:t>• Keyframe Pipeline: Uniform ~1fps sampling &amp; brightness scoring (Case C sample: 28/255)</a:t>
             </a:r>
           </a:p>
           <a:p>
@@ -9752,11 +9752,11 @@
               <a:spcAft>
                 <a:spcPts val="200"/>
               </a:spcAft>
-              <a:defRPr sz="950">
+              <a:defRPr sz="1050">
                 <a:solidFill>
                   <a:srgbClr val="243830"/>
                 </a:solidFill>
-                <a:latin typeface="Inter"/>
+                <a:latin typeface="Calibri"/>
               </a:defRPr>
             </a:pPr>
             <a:r>
@@ -9768,11 +9768,11 @@
               <a:spcAft>
                 <a:spcPts val="200"/>
               </a:spcAft>
-              <a:defRPr sz="950">
+              <a:defRPr sz="1050">
                 <a:solidFill>
                   <a:srgbClr val="243830"/>
                 </a:solidFill>
-                <a:latin typeface="Inter"/>
+                <a:latin typeface="Calibri"/>
               </a:defRPr>
             </a:pPr>
             <a:r>
@@ -9784,11 +9784,11 @@
               <a:spcAft>
                 <a:spcPts val="200"/>
               </a:spcAft>
-              <a:defRPr sz="950">
+              <a:defRPr sz="1050">
                 <a:solidFill>
                   <a:srgbClr val="243830"/>
                 </a:solidFill>
-                <a:latin typeface="Inter"/>
+                <a:latin typeface="Calibri"/>
               </a:defRPr>
             </a:pPr>
             <a:r>
@@ -9806,7 +9806,7 @@
         <p:spPr>
           <a:xfrm>
             <a:off x="8156448" y="2788920"/>
-            <a:ext cx="3611880" cy="2148840"/>
+            <a:ext cx="3611880" cy="2240280"/>
           </a:xfrm>
           <a:prstGeom prst="roundRect">
             <a:avLst/>
@@ -9851,7 +9851,7 @@
         <p:spPr>
           <a:xfrm>
             <a:off x="8321040" y="2916936"/>
-            <a:ext cx="3282696" cy="1929384"/>
+            <a:ext cx="3282696" cy="2020824"/>
           </a:xfrm>
           <a:prstGeom prst="rect">
             <a:avLst/>
@@ -9869,7 +9869,7 @@
                 <a:solidFill>
                   <a:srgbClr val="006B54"/>
                 </a:solidFill>
-                <a:latin typeface="IBM Plex Mono"/>
+                <a:latin typeface="Consolas"/>
               </a:defRPr>
             </a:pPr>
             <a:r>
@@ -9878,11 +9878,11 @@
           </a:p>
           <a:p>
             <a:pPr>
-              <a:defRPr sz="1300" b="1">
+              <a:defRPr sz="1400" b="1">
                 <a:solidFill>
                   <a:srgbClr val="14241E"/>
                 </a:solidFill>
-                <a:latin typeface="Inter"/>
+                <a:latin typeface="Calibri"/>
               </a:defRPr>
             </a:pPr>
             <a:r>
@@ -9898,7 +9898,7 @@
                 <a:solidFill>
                   <a:srgbClr val="5C7066"/>
                 </a:solidFill>
-                <a:latin typeface="IBM Plex Mono"/>
+                <a:latin typeface="Consolas"/>
               </a:defRPr>
             </a:pPr>
             <a:r>
@@ -9910,11 +9910,11 @@
               <a:spcAft>
                 <a:spcPts val="200"/>
               </a:spcAft>
-              <a:defRPr sz="950">
+              <a:defRPr sz="1050">
                 <a:solidFill>
                   <a:srgbClr val="243830"/>
                 </a:solidFill>
-                <a:latin typeface="Inter"/>
+                <a:latin typeface="Calibri"/>
               </a:defRPr>
             </a:pPr>
             <a:r>
@@ -9926,11 +9926,11 @@
               <a:spcAft>
                 <a:spcPts val="200"/>
               </a:spcAft>
-              <a:defRPr sz="950">
+              <a:defRPr sz="1050">
                 <a:solidFill>
                   <a:srgbClr val="243830"/>
                 </a:solidFill>
-                <a:latin typeface="Inter"/>
+                <a:latin typeface="Calibri"/>
               </a:defRPr>
             </a:pPr>
             <a:r>
@@ -9942,11 +9942,11 @@
               <a:spcAft>
                 <a:spcPts val="200"/>
               </a:spcAft>
-              <a:defRPr sz="950">
+              <a:defRPr sz="1050">
                 <a:solidFill>
                   <a:srgbClr val="243830"/>
                 </a:solidFill>
-                <a:latin typeface="Inter"/>
+                <a:latin typeface="Calibri"/>
               </a:defRPr>
             </a:pPr>
             <a:r>
@@ -9958,11 +9958,11 @@
               <a:spcAft>
                 <a:spcPts val="200"/>
               </a:spcAft>
-              <a:defRPr sz="950">
+              <a:defRPr sz="1050">
                 <a:solidFill>
                   <a:srgbClr val="243830"/>
                 </a:solidFill>
-                <a:latin typeface="Inter"/>
+                <a:latin typeface="Calibri"/>
               </a:defRPr>
             </a:pPr>
             <a:r>
@@ -10039,7 +10039,7 @@
                 <a:solidFill>
                   <a:srgbClr val="FFD485"/>
                 </a:solidFill>
-                <a:latin typeface="IBM Plex Mono"/>
+                <a:latin typeface="Consolas"/>
               </a:defRPr>
             </a:pPr>
             <a:r>
@@ -10048,11 +10048,11 @@
           </a:p>
           <a:p>
             <a:pPr>
-              <a:defRPr sz="1100">
+              <a:defRPr sz="1200">
                 <a:solidFill>
                   <a:srgbClr val="DFEAE5"/>
                 </a:solidFill>
-                <a:latin typeface="Inter"/>
+                <a:latin typeface="Calibri"/>
               </a:defRPr>
             </a:pPr>
             <a:r>
@@ -10088,7 +10088,7 @@
                 <a:solidFill>
                   <a:srgbClr val="FF8C69"/>
                 </a:solidFill>
-                <a:latin typeface="IBM Plex Mono"/>
+                <a:latin typeface="Consolas"/>
               </a:defRPr>
             </a:pPr>
             <a:r>
@@ -10097,11 +10097,11 @@
           </a:p>
           <a:p>
             <a:pPr>
-              <a:defRPr sz="1050">
+              <a:defRPr sz="1150">
                 <a:solidFill>
                   <a:srgbClr val="DFEAE5"/>
                 </a:solidFill>
-                <a:latin typeface="Inter"/>
+                <a:latin typeface="Calibri"/>
               </a:defRPr>
             </a:pPr>
             <a:r>
@@ -10137,7 +10137,7 @@
                 <a:solidFill>
                   <a:srgbClr val="00D1A7"/>
                 </a:solidFill>
-                <a:latin typeface="IBM Plex Mono"/>
+                <a:latin typeface="Consolas"/>
               </a:defRPr>
             </a:pPr>
             <a:r>
@@ -10150,7 +10150,7 @@
                 <a:solidFill>
                   <a:srgbClr val="FFFFFF"/>
                 </a:solidFill>
-                <a:latin typeface="IBM Plex Mono"/>
+                <a:latin typeface="Consolas"/>
               </a:defRPr>
             </a:pPr>
             <a:r>
@@ -10227,7 +10227,7 @@
                 <a:solidFill>
                   <a:srgbClr val="8A9C93"/>
                 </a:solidFill>
-                <a:latin typeface="IBM Plex Mono"/>
+                <a:latin typeface="Consolas"/>
               </a:defRPr>
             </a:pPr>
             <a:r>
@@ -10263,7 +10263,7 @@
                 <a:solidFill>
                   <a:srgbClr val="8A9C93"/>
                 </a:solidFill>
-                <a:latin typeface="IBM Plex Mono"/>
+                <a:latin typeface="Consolas"/>
               </a:defRPr>
             </a:pPr>
             <a:r>

</xml_diff>